<commit_message>
Update detailed LLM inference presentation
</commit_message>
<xml_diff>
--- a/大模型推理基础与性能优化_华为红_精修版.pptx
+++ b/大模型推理基础与性能优化_华为红_精修版.pptx
@@ -515,8 +515,11 @@
           <a:p>
             <a:r>
               <a:rPr lang="en-US" dirty="0"/>
-              <a:t>大家好，今天这次分享我们不从模型训练开始讲，而是聚焦一个更贴近业务上线的问题：大模型推理。
-简单说，推理就是模型已经训练好以后，用户给一个输入，模型不断生成输出的过程。今天我会用一个贯穿案例来讲：假设用户输入大约 2000 个 token，模型输出 300 个 token。我们会沿着这个请求，看它经过 Prompt、Tokenize、Prefill、Decode 和 KV Cache，最后再看为什么会慢、为什么会贵，以及常见优化手段分别解决什么问题。</a:t>
+              <a:t>大家好，今天我分享的主题是大模型推理。我们平时聊大模型，很多时候会聊模型能力、训练数据、参数规模，或者具体应用效果。但模型真正进入业务系统以后，另一个问题会变得非常关键：这个模型怎么被高效、稳定、低成本地调用。
+这就是今天要讲的推理。简单说，推理就是模型训练好以后，用户给它一个输入，模型基于这个输入生成输出。它不是训练模型，而是使用模型。
+为了让后面的内容更容易串起来，我会一直用一个例子：假设用户输入大约 2000 个 token，模型输出 300 个 token。我们会沿着这个请求，看它从 Prompt、Tokenize，到 Prefill、Decode，再到 KV Cache 和各种优化手段。大家不需要一开始就理解所有术语，先记住这条主线：大模型推理的核心，是围绕一次请求，尽量把延迟、吞吐和成本平衡好。
+这里可以先给大家一个预期：今天不会深入讲训练算法，也不会讲某一个框架的安装使用，而是先把推理这件事的基本结构讲清楚。对于不熟悉大模型的人，听完以后至少能知道一次请求大概经历了什么；对于已经接触过大模型应用的人，听完以后能更准确地区分，是 Prompt 太长、输出太长、显存不够，还是调度和部署方式带来的问题。
+如果现场有人对 token 不熟悉，可以提前说明：后面我会多次提到 token，大家先把它理解成模型处理文本的最小片段。我们平时看到的是一句话、一段文字，但模型内部看到的是 token 序列。</a:t>
             </a:r>
             <a:endParaRPr lang="en-US" dirty="0"/>
           </a:p>
@@ -604,10 +607,13 @@
           <a:p>
             <a:r>
               <a:rPr lang="en-US" dirty="0"/>
-              <a:t>接下来讲几个常见优化方向。第一个是 batching。
-GPU 最怕的是空转。如果一个请求一个请求地跑，很多时候 GPU 利用率并不高。Batching 的思路是把多个请求合并，让 GPU 一次处理更多 token，从而提高吞吐。
-但大模型推理的 batch 不像普通离线任务那么简单。不同请求输入长度不同、输出长度不同，有的请求已经结束，有的还在继续生成。如果静态 batch 处理，短请求会被 padding 到长请求，产生空算。Continuous batching 的思路是请求完成就移出，新请求及时补进来，让 batch 更连续。
-代价是调度复杂，而且如果一味追求吞吐，低延迟请求可能需要等队列。</a:t>
+              <a:t>接下来进入几个常见优化方向。第一个是 Batching。
+如果一个请求一个请求地跑，GPU 经常不能被充分利用。Batching 的思路是把多个请求合并起来，让 GPU 一次处理更多工作，提高整体吞吐。
+但大模型推理的 batching 比普通任务复杂。因为每个请求的输入长度和输出长度都不一样。比如一个请求很快生成完了，另一个还在继续输出。如果用静态 batch，短请求结束后的位置可能被浪费，或者为了对齐长请求产生 padding 空算。
+Continuous batching 的思路是动态管理 batch。已经完成的请求及时移出，新来的请求及时补进来，让 GPU 尽量持续有工作做。这类能力也是很多推理框架的重要优化点。
+Batching 的收益是提高吞吐、降低单位 token 成本。代价是调度复杂，而且如果系统为了吞吐攒太多请求，低延迟请求可能会排队更久。所以实际线上要根据业务场景调平衡：聊天场景不能只追求吞吐，批处理场景则可以更激进地做 batch。
+可以把 batching 和餐厅排队做个类比。GPU 像厨房，如果一次只做一份菜，厨房可能有很多时间在等；如果把多份菜一起处理，厨房利用率更高。但如果为了凑一大桌，让先来的简单菜一直等，用户体验也会变差。
+所以线上 batching 通常需要策略。比如设置最大等待时间，超过时间就算 batch 不满也要发出去；或者给高优先级业务更短等待；或者把长输出请求和短输出请求分开调度。Continuous batching 的价值就在于更灵活地把不同请求混合起来，让 GPU 利用率更平稳。</a:t>
             </a:r>
             <a:endParaRPr lang="en-US" dirty="0"/>
           </a:p>
@@ -695,9 +701,13 @@
           <a:p>
             <a:r>
               <a:rPr lang="en-US" dirty="0"/>
-              <a:t>第二个优化方向是量化。模型默认可能用 FP16 或 BF16 表示权重和计算。如果改成 INT8、INT4 这样的低位宽，就能降低显存占用，也可能提高吞吐。
-量化可以作用在模型权重上，也可以作用在 KV Cache 上。权重量化能让模型更小，KV Cache 量化能缓解长上下文和高并发时的显存压力。
-但量化不是免费加速。位宽越低，精度风险越高；并且是否真的变快，还取决于硬件和 kernel 是否支持。实际落地时，不能只看 benchmark，要用业务测试集验证回答质量是否可接受。</a:t>
+              <a:t>第二个优化方向是量化。
+模型权重和计算默认可能使用 FP16 或 BF16。如果改成 INT8、INT4 这样的低位宽表示，模型会更小，显存占用会下降，某些硬件上推理速度也可能提升。
+量化可以作用在不同位置。最常见的是权重量化，把模型权重从 16 位降到 8 位或 4 位。也可以做 KV Cache 量化，用更低位宽保存 KV Cache，从而缓解长上下文和高并发时的显存压力。
+这里要注意，量化不是单纯的压缩文件。位宽降低后，数值精度会变低，模型输出质量可能受影响。不同模型、不同任务对量化的敏感程度也不同。有些场景，比如分类、简单问答，损失可能很小；有些场景，比如复杂推理、代码生成、数学题，影响可能更明显。
+所以落地量化时，通常要同时看三件事：显存和吞吐收益、硬件和 kernel 是否支持、业务测试集上的质量变化。只有这三方面都能接受，量化才适合上线。
+量化这里可以再解释 FP16、INT8、INT4 的直觉。FP16 是 16 位浮点数，表达范围和精度比较适合深度学习推理；INT8 和 INT4 用更少的位保存数值，所以同样显存能放下更多参数或缓存。显存减少以后，也可能减少数据搬运量，从而提升速度。
+但量化会引入误差。工程上常见的量化方法，比如 GPTQ、AWQ、SmoothQuant，本质上都是想在降低位宽的同时尽量保持模型输出质量。上线前一般要用业务样本评估，比如问答准确率、格式遵守、代码可用性、拒答率、幻觉率等，而不只看困惑度或通用 benchmark。</a:t>
             </a:r>
             <a:endParaRPr lang="en-US" dirty="0"/>
           </a:p>
@@ -785,9 +795,13 @@
           <a:p>
             <a:r>
               <a:rPr lang="en-US" dirty="0"/>
-              <a:t>第三个方向是推理框架。像 vLLM、TensorRT-LLM、SGLang、TGI 这类框架，本质价值不只是帮我们把模型跑起来，而是把很多优化工程化。
-比如调度层面，它们支持动态 batch、队列、优先级。KV 管理层面，有 PagedAttention、prefix cache、KV offload 等能力。算子层面，有 FlashAttention、fused kernel、量化 kernel。分布式层面，会支持张量并行、流水线并行、数据并行和服务路由。
-选型时不要只看单个 benchmark，还要看模型是否支持、硬件栈是否匹配、运维复杂度，以及和现有网关、监控、日志系统怎么集成。</a:t>
+              <a:t>第三个方向是推理框架。这里可以把推理框架理解成一套把模型服务化的系统。
+像 vLLM、TensorRT-LLM、SGLang、TGI 这些框架，主要价值在于把很多推理优化工程化，形成稳定可复用的能力。它们不是只负责把模型加载起来，而是把调度、KV 管理、算子优化和分布式能力组合到一起。
+调度层面，框架会处理动态 batching、队列、优先级和并发控制。KV 管理层面，会有 PagedAttention、Prefix Cache、KV offload 等机制。算子层面，会用 FlashAttention、fused kernel、量化 kernel 来提升计算效率。分布式层面，会支持张量并行、流水线并行、数据并行以及服务路由。
+所以选推理框架时，可以同时看几个维度：模型是否支持，硬件栈是否匹配，吞吐和延迟是否满足目标，运维复杂度是否可控，以及它和现有网关、监控、日志、计费系统怎么集成。
+这一页图里的意思是：这些优化能力最后都会汇聚到推理框架里，由框架统一调度和管理。
+这一页可以进一步讲框架选型的实际问题。比如 vLLM 在 KV Cache 管理和 continuous batching 上很有代表性，TensorRT-LLM 更强调 NVIDIA 生态下的高性能 kernel 和部署优化，SGLang 在结构化生成、agent、多请求编排上有自己的优势，TGI 更偏 Hugging Face 生态的服务化部署。
+这里不需要现场比较哪个最好，因为框架没有绝对最优。更实际的判断是：我们要跑什么模型，用什么硬件，业务更关注低延迟还是高吞吐，是否需要多机部署，团队能不能维护这套系统。把这些维度放在一起看，选型会更稳。</a:t>
             </a:r>
             <a:endParaRPr lang="en-US" dirty="0"/>
           </a:p>
@@ -875,9 +889,13 @@
           <a:p>
             <a:r>
               <a:rPr lang="en-US" dirty="0"/>
-              <a:t>第四个方向是多卡和多机部署。单卡有两个限制：一是模型可能放不下，二是吞吐不够。
-常见并行方式有三类。Tensor Parallel 是把同一层里的矩阵计算拆到多张卡上，适合单层很大或者模型放不下。Pipeline Parallel 是把不同层放到不同卡上，适合超大模型，但会有流水线气泡。Data Parallel 是复制多份模型，不同副本服务不同请求，主要用于提升总体吞吐。
-多机以后，新的问题是通信。NCCL、RDMA、InfiniBand、网络拓扑和故障恢复都会影响性能和稳定性。所以多卡不是简单堆 GPU，而是在容量和通信成本之间做取舍。</a:t>
+              <a:t>第四个方向是多卡和多机部署。
+为什么需要多卡？主要有两个原因。第一，模型太大，单卡放不下。第二，单卡能放下，但吞吐不够，需要更多 GPU 一起服务请求。
+常见并行方式有三类。Tensor Parallel 是把同一层里的矩阵计算拆到多张卡上，适合单层计算很大或者模型放不下的场景。Pipeline Parallel 是把不同层放到不同卡上，模型像流水线一样经过多张卡，适合更大的模型，但会有流水线气泡。Data Parallel 是复制多份模型，不同副本处理不同请求，主要用于提升整体吞吐。
+多卡多机带来的收益是容量提升，但也会引入新的成本。卡和卡之间、机器和机器之间需要通信。比如 tensor parallel 中不同卡要交换中间结果；多机部署还涉及 NCCL、RDMA、InfiniBand、网络拓扑和故障恢复。
+所以多卡不是简单增加 GPU 数量。它解决放不下和跑不快的问题，同时也会把通信、同步、容错和运维复杂度带进来。
+多卡多机这里可以补充一点：并行方式往往会组合使用。比如一个超大模型可能同时用 tensor parallel 把单层拆开，又用 pipeline parallel 把层拆开；如果服务多个用户，还会有 data parallel 或多副本部署。实际系统里不是三选一，而是根据模型大小、显存、吞吐目标和网络条件组合。
+通信开销也可以讲得更具体：如果每一层计算后都要跨卡交换数据，那么网络延迟和带宽会影响整体速度。单机多卡通常通信快一些，多机跨节点通信复杂得多。硬件拓扑、IB 网络、NCCL 配置、故障恢复都会影响最终稳定性。</a:t>
             </a:r>
             <a:endParaRPr lang="en-US" dirty="0"/>
           </a:p>
@@ -966,9 +984,13 @@
             <a:r>
               <a:rPr lang="en-US" dirty="0"/>
               <a:t>最后讲 PD 分离，也就是 Prefill 和 Decode 分离。
-前面说过，Prefill 和 Decode 的资源特征不同。Prefill 更像一次性处理长输入，计算密集，主要影响 TTFT。Decode 是持续生成输出，循环次数多，更受带宽、KV Cache 和调度影响。
-PD 分离的思路是把 Prefill 节点和 Decode 节点拆开。Prefill 池专门处理长 prompt，生成 KV Cache；然后把 KV Cache 交给 Decode 池继续生成。这样两个阶段可以分别扩容，也更容易匹配资源。
-它的挑战也很明显：KV Cache 要传输，网络压力会上来，调度和请求生命周期也更复杂。所以不是所有场景都要 PD 分离，通常是长上下文、高并发、首 token 时间敏感时更有价值。</a:t>
+前面我们说过，Prefill 和 Decode 的资源特征不同。Prefill 更像一次性处理长输入，计算密集，主要影响 TTFT。Decode 是持续生成输出，循环次数多，更受内存带宽、KV Cache 和调度影响。
+PD 分离的思路是把这两个阶段拆到不同资源池里。Prefill Pool 专门处理长 prompt，快速完成输入上下文处理并生成 KV Cache。之后把 KV Cache 传给 Decode Pool，由 Decode 节点继续逐 token 生成。
+这样做的收益是资源可以按阶段扩容。比如某个业务输入很长但输出不长，可以增加 Prefill 能力；另一个业务输出很长，可以增加 Decode 能力。这样比所有请求都混在同一组 GPU 上更容易做资源匹配。
+挑战也很明显。KV Cache 要在 Prefill 和 Decode 之间传输，网络压力会上来；请求生命周期也更复杂，需要调度系统知道请求处在哪个阶段。通常在长上下文、高并发、首 token 时间敏感的场景里，PD 分离更有价值。
+到这里，我们就把推理的主链路和常见优化方向串起来了。核心思路是：先拆清楚 Prefill 和 Decode，再根据瓶颈选择 KV Cache、batching、量化、推理框架、多卡多机或 PD 分离这些手段。
+PD 分离可以用资源错配来解释。Prefill 需要短时间处理大量输入，像一次性读很多材料；Decode 需要较长时间稳定输出，像持续写答案。如果把两类请求都混在同一批 GPU 上，可能出现 Prefill 抢占 Decode，或者 Decode 占着资源导致 Prefill 排队。
+分离以后，Prefill Pool 和 Decode Pool 可以分别调度。比如长文档问答可以给 Prefill 更多资源，聊天式长输出可以给 Decode 更多资源。不过它也增加了系统复杂度：KV Cache 怎么传、失败怎么恢复、请求怎么追踪、两个资源池怎么做负载均衡，都需要工程设计。可以把它理解为更高级的推理系统优化，而不是入门阶段必须马上使用的能力。</a:t>
             </a:r>
             <a:endParaRPr lang="en-US" dirty="0"/>
           </a:p>
@@ -1056,9 +1078,14 @@
           <a:p>
             <a:r>
               <a:rPr lang="en-US" dirty="0"/>
-              <a:t>为什么部门里需要理解推理？因为大模型应用上线以后，很多问题表面上是“模型效果”或者“接口慢”，但真正落点往往在推理系统。
-第一是体验。用户最敏感的是多久看到第一个字，也就是首 token 时间；同时也会感知输出是否顺滑，也就是每个 token 的生成速度。第二是成本。大模型服务的成本很多时候不是按请求算，而是按 token、按 GPU 时间算。第三是容量，并发上来以后，GPU 是否空转、显存是否够、队列是否堆积，都会影响服务能力。第四是稳定性，长 prompt、长输出和突发流量都可能导致 OOM 或慢请求。
-所以这次分享的目标不是把所有底层细节讲完，而是让大家建立判断推理问题的框架。</a:t>
+              <a:t>先说为什么需要理解推理。对一个大模型应用来说，用户最终感受到的不是模型参数有多少，也不是底层用了什么框架，而是这个系统回答得快不快、稳不稳、贵不贵。
+第一是体验。比如一个聊天机器人，如果用户发完问题以后，三四秒都没有第一个字出来，用户会觉得系统卡住了。这个就是首 token 时间，也就是 TTFT。再比如第一个字出来了，但是后面一个字一个字很慢，也会影响流式体验，这对应后面会讲的 TPOT。
+第二是成本。大模型推理通常消耗 GPU 资源，而且成本经常和 token 数量、并发数、上下文长度相关。同样一个模型，同样一张卡，如果调度、batch、KV Cache 管理不同，单位 token 成本可能差很多。
+第三是容量。业务流量上来以后，系统能不能扛住，不只看模型本身，还要看 GPU 利用率、显存、队列等待和服务路由。
+第四是稳定性。线上最常见的问题包括长 prompt、长输出、突发并发、显存打满、慢请求堆积。这些问题很多都属于推理系统问题。
+所以理解推理的意义，不是为了背术语，而是为了遇到问题时能判断：慢在哪里，贵在哪里，优化应该从哪里下手。
+这里可以结合部门业务举一个更具体的例子。比如一个智能客服或知识问答系统，用户最直接的体验是“点了以后多久有反应”。如果首 token 慢，用户会以为系统挂了；如果后续输出慢，用户会觉得答案生成很费劲。对业务侧来说，这直接影响转化率、使用意愿和投诉率。
+成本也可以讲得更落地一点：同样是回答一个问题，如果 Prompt 里塞了很多不必要的历史上下文，输入 token 会变多；如果没有限制输出长度，模型可能生成很长的答案，输出 token 会变多。token 一多，就意味着 GPU 工作更多、KV Cache 占用更多、请求耗时更长。所以推理优化不只是底层工程，也和产品设计、Prompt 设计、RAG 裁剪都有关系。</a:t>
             </a:r>
             <a:endParaRPr lang="en-US" dirty="0"/>
           </a:p>
@@ -1146,9 +1173,13 @@
           <a:p>
             <a:r>
               <a:rPr lang="en-US" dirty="0"/>
-              <a:t>先把训练和推理区分清楚。训练的目标是让模型学会能力，本质上是通过大量数据做前向、反向和参数更新。训练通常更关注收敛、精度、训练效率，以及训练过程是不是稳定。
-推理不一样。推理时模型参数已经固定，我们要做的是把用户输入送进模型，然后生成结果。它更像一个线上系统问题：用户等不等得起，GPU 成本高不高，并发上来后服务能不能稳住。
-所以训练里常说的是 loss、epoch、收敛；推理里更常说的是 TTFT、TPOT、吞吐、显存和成本。后面所有概念基本都围绕这几个指标展开。</a:t>
+              <a:t>接下来把训练和推理区分一下。训练的目标是让模型学会能力。比如我们拿大量语料、代码、图片或者指令数据，让模型通过前向、反向传播和参数更新，逐步学到模式。训练更关注的是收敛、精度、loss、训练效率，以及训练过程是否稳定。
+推理不一样。推理时，模型参数已经固定了。我们不再更新模型参数，而是把用户输入送进去，让模型根据已有参数生成输出。这个阶段更像一个线上服务问题。
+举个类比，训练像是培养一个专家，让他通过大量资料学习。推理像是让这个专家坐到服务台前，不断回答用户问题。训练阶段关心专家学得怎么样，推理阶段关心他回答得快不快、服务多少人、每次服务成本是多少。
+所以训练和推理关注的指标也不同。训练里常说 loss、epoch、梯度、吞吐。推理里更常说 TTFT、TPOT、throughput、显存、QPS、单 token 成本。
+这也是为什么一个模型效果很好，不代表线上体验一定好。模型能力是一部分，推理系统决定了这个能力能不能以可接受的速度和成本交付出去。
+可以再补充一个容易混淆的点：训练和推理都需要“前向计算”，但训练还要做反向传播和参数更新，所以训练的计算链路更重；推理只做前向生成，但它的难点在于要面向线上用户持续服务。也就是说，推理单次看起来比训练简单，但在线上系统里，它会遇到并发、排队、服务稳定性和成本控制问题。
+还可以强调：训练通常是离线批量任务，可以提前规划资源和时间；推理通常是在线实时任务，用户什么时候来请求是不确定的。这个“不确定”就是推理系统需要调度、限流、排队和监控的原因。</a:t>
             </a:r>
             <a:endParaRPr lang="en-US" dirty="0"/>
           </a:p>
@@ -1236,9 +1267,13 @@
           <a:p>
             <a:r>
               <a:rPr lang="en-US" dirty="0"/>
-              <a:t>接下来讲大模型如何生成答案。很多人直觉上会以为模型像搜索引擎一样，一次计算就返回完整答案。但大模型通常是自回归生成，也就是每一步只预测下一个 token。
-比如用户输入“请解释大模型推理为什么慢”，模型先根据这段上下文预测第一个输出 token。得到第一个 token 后，它会把这个 token 加入上下文，再预测第二个。这个过程会一直循环，直到达到结束条件或者 max tokens。
-这就带来一个非常重要的直觉：输出越长，循环越多，请求耗时就越长。输入越长，模型在生成第一个 token 之前要处理的上下文越多，首 token 时间就越长。</a:t>
+              <a:t>这一页讲大模型到底是怎么生成答案的。很多人直觉上会以为，大模型收到问题以后，会在内部思考一遍，然后一次性把完整答案吐出来。但实际并不是这样。
+大多数大语言模型采用的是自回归生成。所谓自回归，可以简单理解为：模型每一步只预测下一个 token。比如用户问“请解释大模型推理为什么慢”，模型先根据输入上下文预测第一个输出 token。第一个 token 出来以后，模型会把它也放进上下文里，再预测第二个 token。这个过程不断循环，直到生成结束符，或者达到最大输出长度。
+这里要解释一下 token。Token 不完全等同于汉字或单词，它是模型处理文本的基本单位。中文里一个 token 可能是一个字，也可能是一个词的一部分；英文里可能是一个单词，也可能是单词片段。我们平时说输入 2000 token、输出 300 token，就是按模型看到的这些基本单位来算。
+这个机制带来两个非常重要的直觉。第一，输入越长，模型在生成第一个 token 之前要看的上下文越多，所以首 token 时间可能更长。第二，输出越长，Decode 循环次数越多，所以整体生成时间也会更长。
+后面讲 Prefill、Decode、KV Cache，其实都和这个逐 token 生成机制有关。
+这里可以展开讲一下为什么逐 token 生成会导致延迟不可避免。假设模型输出 300 个 token，不管单个 token 生成得多快，都需要至少 300 轮 Decode。每一轮都要读模型权重、读历史 KV Cache、计算下一个 token 的概率分布，然后再选择一个 token。这就是为什么大模型生成长答案时，耗时会随着输出长度线性增加。
+还可以顺带解释生成参数。temperature、top-p、top-k 这些参数决定模型在候选 token 里怎么选择。它们主要影响输出的随机性和多样性，不会改变“逐 token 生成”这个基本事实。max tokens 则会直接限制输出长度，因此它既影响成本，也影响延迟。</a:t>
             </a:r>
             <a:endParaRPr lang="en-US" dirty="0"/>
           </a:p>
@@ -1326,9 +1361,14 @@
           <a:p>
             <a:r>
               <a:rPr lang="en-US" dirty="0"/>
-              <a:t>现在把一次请求拆开看。用户请求进来以后，系统通常先做 Prompt 构造。这里可能包含系统提示词、用户问题，也可能包含 RAG 检索出来的知识片段。
-接着是 Tokenize，把文本切成模型认识的 token。然后进入模型计算，先是 Prefill，一次性处理输入上下文；再是 Decode，逐 token 生成输出。生成出来的 token 要经过 Detokenize 转回文本，再通过流式方式返回给前端。
-除了这条主链路，线上系统还会有鉴权、限流、排队、监控、日志、计费、模型路由等外围能力。很多慢请求并不一定慢在模型本身，也可能慢在排队、检索、tokenizer 或网关侧。</a:t>
+              <a:t>现在把一次推理请求拆成完整链路来看。
+第一步是 Prompt 构造。真实业务里，用户问题通常不是直接丢给模型。系统可能会加系统提示词，比如角色、回答格式、约束条件；如果是 RAG 场景，还会拼接检索出来的知识片段；如果是多轮对话，还会带上历史上下文。
+第二步是 Tokenize，把文本切成模型能够识别的 token。这个步骤看起来简单，但在高并发场景下，tokenizer 性能也可能成为瓶颈。
+第三步是 Prefill。模型会一次性处理输入上下文，建立后续生成需要的内部状态。第四步是 Decode，也就是逐 token 生成输出。生成出来的 token 还要 Detokenize，转回人能读的文本，然后通过流式方式返回给前端。
+除了这条主链路，线上还会有鉴权、限流、排队、监控、日志、计费、模型路由等能力。很多时候用户感觉慢，不一定慢在模型计算，也可能慢在排队、检索、网关、tokenizer 或后处理。
+所以看推理链路时，我们要避免只看一个端到端耗时，而是把它拆成多个阶段分析。
+这一页可以强调“链路上每一步都可能带来延迟”。比如 Prompt 构造阶段，如果 RAG 检索慢，模型还没开始算，请求就已经慢了；Tokenize 阶段如果在 CPU 上处理大量文本，也可能拖慢；模型阶段又分成 Prefill 和 Decode；最后 Detokenize 和流式返回也会影响用户看到内容的节奏。
+如果现场有工程同学，可以补一句：线上排查最好做 trace，把一次请求按阶段打点。比如记录 queue time、tokenize time、prefill time、decode token/s、detokenize time。只有这样，看到慢请求时才知道该看 GPU、看检索、看网关，还是看调度队列。</a:t>
             </a:r>
             <a:endParaRPr lang="en-US" dirty="0"/>
           </a:p>
@@ -1416,10 +1456,13 @@
           <a:p>
             <a:r>
               <a:rPr lang="en-US" dirty="0"/>
-              <a:t>推理链路里最核心的是 Prefill 和 Decode。
-Prefill 是模型看到输入 prompt 后，先把整个输入上下文处理一遍。它一次性处理很多 token，并行度比较高，所以更偏计算密集。对于用户来说，Prefill 主要影响首 token 时间，也就是用户多久能看到第一个输出。
-Decode 是生成阶段。每一步只生成一个 token，然后把新 token 加回上下文，再生成下一个 token。输出 300 个 token，就意味着 Decode 至少循环 300 次。这个阶段更容易受内存带宽、KV Cache 读取和调度影响。
-所以一个判断规则是：输入长，先看 Prefill；输出长，重点看 Decode。</a:t>
+              <a:t>这里是今天最核心的一页：Prefill 和 Decode。
+Prefill 可以理解为模型先阅读输入。假设用户输入 2000 个 token，模型在生成第一个输出 token 之前，需要把这 2000 个 token 处理一遍。这个阶段一次性处理大量输入，并行度比较高，所以更偏计算密集。它直接影响 TTFT，也就是用户多久能看到第一个输出。
+Decode 可以理解为模型开始写答案。每一步生成一个新 token，然后把新 token 加回上下文，再生成下一个。如果输出 300 个 token，就至少要循环 300 次。这个阶段每次只生成一个 token，看起来计算量不如 Prefill 大，但因为要反复读取模型权重和 KV Cache，所以更容易受显存带宽、调度和缓存管理影响。
+这两个阶段的资源特征不同，所以优化方向也不同。长输入场景，比如 RAG 拼了很多文档，主要会压 Prefill。长输出场景，比如让模型写长报告、长代码，主要会压 Decode。
+我们后面讲性能指标、KV Cache、Batching、PD 分离，本质上都是围绕这两个阶段展开的。记住一个简单判断：输入长，先看 Prefill；输出长，重点看 Decode。
+这里可以用刚才的 2000 输入、300 输出例子再讲一遍。Prefill 面对的是 2000 个输入 token，所以它的工作量和输入长度强相关。Decode 面对的是 300 个输出 token，所以它至少要循环 300 次。两者都在同一个请求里，但瓶颈可能完全不同。
+可以再补一个业务判断方法：如果用户问题里带了很多文档、很多历史对话，首 token 慢，通常优先怀疑 Prefill；如果第一个 token 出来很快，但后面输出很慢，通常优先看 Decode、KV Cache、batch 调度和显存带宽。这个判断不一定百分百准确，但作为第一步排查很有用。</a:t>
             </a:r>
             <a:endParaRPr lang="en-US" dirty="0"/>
           </a:p>
@@ -1507,9 +1550,14 @@
           <a:p>
             <a:r>
               <a:rPr lang="en-US" dirty="0"/>
-              <a:t>推理性能不要只看一个总耗时。这里有四类指标最重要。
-TTFT 是 Time To First Token，也就是首 token 时间。它决定用户是否觉得系统“有响应”。TPOT 是 Time Per Output Token，也就是每个输出 token 的平均耗时。它决定流式输出是否顺滑。Throughput 是吞吐，可以按 tokens per second，也可以按 requests per second 看，它决定一组 GPU 能扛多少量。
-还有显存和成本。显存不仅要放模型权重，还要放 KV Cache。并发越高、上下文越长，显存压力越大。业务上真正要平衡的是：用户体验、系统吞吐和单 token 成本。</a:t>
+              <a:t>推理性能可以从四类指标来看。
+第一是 TTFT，Time To First Token，也就是首 token 时间。用户发起请求以后，多久能看到第一个字，主要看这个指标。它和排队时间、Prompt 长度、Prefill 计算、调度都有关系。聊天类应用里，TTFT 非常影响用户体感。
+第二是 TPOT，Time Per Output Token，也就是每个输出 token 的耗时。如果 TPOT 比较稳定，用户会觉得输出是连续流畅的；如果 TPOT 抖动比较大，流式输出就会一卡一卡。
+第三是 Throughput，也就是吞吐。可以按 tokens per second 看，也可以按 requests per second 看。吞吐关心的是一组 GPU 单位时间能处理多少工作。对批处理、离线生成、大规模服务来说，吞吐非常重要。
+第四是显存和成本。显存要放模型权重，也要放 KV Cache。上下文越长，并发越高，KV Cache 越大，显存压力越高。成本则和 GPU 时间、token 数量、模型大小、利用率都有关系。
+所以不同业务场景关注点不同。聊天机器人更关注 TTFT 和 TPOT；批量生成更关注吞吐；长文档问答更关注 Prefill 成本和 KV Cache；企业内部服务还要关注单次调用成本和稳定性。
+可以把这些指标和用户体验对应起来。TTFT 低，用户觉得系统响应快；TPOT 稳，用户觉得输出流畅；Throughput 高，系统能服务更多用户；显存和成本可控，业务才能规模化上线。很多优化不是单独追一个指标，而是多个指标一起权衡。
+举例来说，增大 batch 可能提高 Throughput，但也可能让某些请求排队更久，TTFT 变差。量化可能降低显存和成本，但可能影响模型质量。多卡部署能提升容量，但通信开销可能影响 TPOT。所以看指标时要先明确业务优先级：是体验优先、吞吐优先，还是成本优先。</a:t>
             </a:r>
             <a:endParaRPr lang="en-US" dirty="0"/>
           </a:p>
@@ -1597,9 +1645,15 @@
           <a:p>
             <a:r>
               <a:rPr lang="en-US" dirty="0"/>
-              <a:t>推理慢和贵通常不是单点原因，而是多个资源瓶颈叠加。
-计算瓶颈主要出现在 Prefill，尤其是长上下文、大模型时，矩阵乘法和 attention 计算都很重。显存瓶颈来自模型权重、KV Cache 和并发请求。带宽瓶颈常见于 Decode，因为每生成一个 token 都要反复读权重和 KV Cache。调度瓶颈来自请求长短不一，batch 组不满，或者队列等待。多卡多机以后，还会有网络瓶颈，比如跨节点通信和 KV 传输。
-排查时不要只说接口慢，而要拆成排队、Prefill、Decode、网络和后处理几个阶段。</a:t>
+              <a:t>这一页回答一个常见问题：推理为什么慢、为什么贵。
+第一类瓶颈是计算。Prefill 阶段要处理完整输入，尤其是长上下文和大模型时，矩阵乘法和 Attention 计算都比较重。
+第二类是显存。显存里不只放模型权重，还要放 KV Cache 和一些运行时状态。模型越大、上下文越长、并发越高，显存压力越明显。
+第三类是内存带宽。Decode 阶段每生成一个 token 都要读取模型权重和历史 KV Cache。这个阶段很多时候不是算力不够，而是数据搬运跟不上。
+第四类是调度。线上请求长度不一样，有的请求输入很长，有的输出很长，有的很快结束，有的持续生成。如果调度不好，batch 可能组不满，GPU 会空转，或者短请求被长请求拖住。
+第五类是网络。单机单卡时网络不是重点，但多卡多机以后，跨卡通信、跨节点同步、KV Cache 传输都会变成成本。
+所以定位推理问题时，可以先把端到端耗时拆成几个部分：排队、Prefill、Decode、网络和后处理。这样更容易知道真正该优化哪里。
+这一页可以多讲一下不同瓶颈出现的典型场景。计算瓶颈常见于长输入、超大模型、Prefill 很重的请求。显存瓶颈常见于高并发、长上下文、多轮对话，尤其是 KV Cache 堆起来以后。带宽瓶颈常见于 Decode，因为每一步都要读很多历史状态。
+调度瓶颈则更隐蔽。比如一批请求里有的输出 20 token，有的输出 2000 token，如果调度策略不好，短请求可能被长请求影响。网络瓶颈通常在多卡多机时出现，比如张量并行需要跨卡同步，PD 分离需要传 KV Cache。把这些场景讲出来，听众会更容易把瓶颈和真实问题对应上。</a:t>
             </a:r>
             <a:endParaRPr lang="en-US" dirty="0"/>
           </a:p>
@@ -1687,10 +1741,13 @@
           <a:p>
             <a:r>
               <a:rPr lang="en-US" dirty="0"/>
-              <a:t>KV Cache 是理解大模型推理非常关键的概念。
-在 Transformer 里，每个 token 会产生 Key 和 Value。生成下一个 token 时，模型需要关注历史上下文。如果没有 KV Cache，每生成一个新 token，都要对历史 token 做重复计算，成本很高。
-有了 KV Cache 之后，历史 token 的 Key 和 Value 会被缓存下来。Decode 时只需要读取这些缓存，再为新 token 追加新的 K/V。这样 Decode 会快很多。
-但代价也很明显：KV Cache 占显存。上下文越长、batch 越大、并发越高，KV Cache 越大。所以长上下文和高并发场景，很多时候瓶颈不是模型权重，而是 KV Cache。</a:t>
+              <a:t>KV Cache 是理解推理系统非常关键的概念。
+Transformer 在处理 token 时，会为每一层 attention 产生 Key 和 Value。生成下一个 token 时，模型需要关注之前所有 token。如果每次生成新 token 都重新计算历史上下文，Decode 会非常慢。
+KV Cache 的思路是，把历史 token 对应的 Key 和 Value 缓存下来。下一步生成时，不需要重新计算所有历史 token，只需要读取已有缓存，再为新 token 追加新的 K/V。这样可以大幅降低 Decode 阶段的重复计算。
+它的收益很直接：输出生成更快，尤其是长输出时非常重要。但代价也很直接：占显存。KV Cache 的规模大致和层数、batch size、上下文长度、hidden 维度、数据精度相关。上下文越长，并发越高，KV Cache 越大。
+所以线上经常会看到一个现象：模型权重本身能放下，但并发一高、上下文一长，显存还是被 KV Cache 打满。很多长上下文优化，比如 PagedAttention、Prefix Cache、KV Cache 量化、KV offload，本质上都是围绕这个问题做文章。
+这里可以补一个显存直觉。模型权重是相对固定的，比如一个模型加载上来以后，权重占用基本稳定；但 KV Cache 是随请求变化的。并发越高，正在生成的请求越多；上下文越长，每个请求缓存的历史 token 越多；输出越长，请求占用 KV Cache 的时间也越长。
+所以 KV Cache 管理是推理框架的核心能力之一。PagedAttention 的思路可以类比操作系统的分页，把 KV Cache 切成块来管理，减少内存碎片。Prefix Cache 可以复用相同前缀，比如多个请求共享同一段系统提示词或文档前缀。KV Cache 量化和 offload 则是在显存不够时，用精度或速度换容量。</a:t>
             </a:r>
             <a:endParaRPr lang="en-US" dirty="0"/>
           </a:p>
@@ -3337,7 +3394,7 @@
                 <a:ea typeface="Microsoft YaHei" pitchFamily="34" charset="-122"/>
                 <a:cs typeface="Microsoft YaHei" pitchFamily="34" charset="-120"/>
               </a:rPr>
-              <a:t>Batching 的核心不是“攒请求”，而是让 GPU 持续有活干。</a:t>
+              <a:t>Batching 的目标是让 GPU 更连续地处理请求。</a:t>
             </a:r>
             <a:endParaRPr lang="en-US" sz="1320" dirty="0"/>
           </a:p>
@@ -5144,11 +5201,11 @@
             </a:avLst>
           </a:prstGeom>
           <a:solidFill>
-            <a:srgbClr val="FFF1F2"/>
-          </a:solidFill>
-          <a:ln w="10160">
-            <a:solidFill>
-              <a:srgbClr val="F2C7CB"/>
+            <a:srgbClr val="FFFFFF"/>
+          </a:solidFill>
+          <a:ln w="9525">
+            <a:solidFill>
+              <a:srgbClr val="DCDCDC"/>
             </a:solidFill>
             <a:prstDash val="solid"/>
           </a:ln>
@@ -5163,7 +5220,7 @@
         <p:spPr>
           <a:xfrm>
             <a:off x="804672" y="5650992"/>
-            <a:ext cx="100584" cy="493776"/>
+            <a:ext cx="91440" cy="493776"/>
           </a:xfrm>
           <a:prstGeom prst="rect">
             <a:avLst/>
@@ -5187,8 +5244,47 @@
         </p:nvSpPr>
         <p:spPr>
           <a:xfrm>
-            <a:off x="1078992" y="5815584"/>
-            <a:ext cx="9921240" cy="118872"/>
+            <a:off x="1051560" y="5760720"/>
+            <a:ext cx="713232" cy="91440"/>
+          </a:xfrm>
+          <a:prstGeom prst="rect">
+            <a:avLst/>
+          </a:prstGeom>
+          <a:noFill/>
+          <a:ln/>
+        </p:spPr>
+        <p:txBody>
+          <a:bodyPr wrap="square" lIns="0" tIns="0" rIns="0" bIns="0" rtlCol="0" anchor="ctr"/>
+          <a:lstStyle/>
+          <a:p>
+            <a:pPr indent="0" marL="0">
+              <a:buNone/>
+            </a:pPr>
+            <a:r>
+              <a:rPr lang="en-US" sz="720" b="1" dirty="0">
+                <a:solidFill>
+                  <a:srgbClr val="C7000B"/>
+                </a:solidFill>
+                <a:latin typeface="Microsoft YaHei" pitchFamily="34" charset="0"/>
+                <a:ea typeface="Microsoft YaHei" pitchFamily="34" charset="-122"/>
+                <a:cs typeface="Microsoft YaHei" pitchFamily="34" charset="-120"/>
+              </a:rPr>
+              <a:t>本页要点</a:t>
+            </a:r>
+            <a:endParaRPr lang="en-US" sz="720" dirty="0"/>
+          </a:p>
+        </p:txBody>
+      </p:sp>
+      <p:sp>
+        <p:nvSpPr>
+          <p:cNvPr id="79" name="Text 77"/>
+          <p:cNvSpPr/>
+          <p:nvPr/>
+        </p:nvSpPr>
+        <p:spPr>
+          <a:xfrm>
+            <a:off x="1874520" y="5815584"/>
+            <a:ext cx="9006840" cy="118872"/>
           </a:xfrm>
           <a:prstGeom prst="rect">
             <a:avLst/>
@@ -5202,21 +5298,21 @@
           </a:bodyPr>
           <a:lstStyle/>
           <a:p>
-            <a:pPr algn="ctr" indent="0" marL="0">
-              <a:buNone/>
-            </a:pPr>
-            <a:r>
-              <a:rPr lang="en-US" sz="1070" b="1" dirty="0">
-                <a:solidFill>
-                  <a:srgbClr val="C7000B"/>
-                </a:solidFill>
-                <a:latin typeface="Microsoft YaHei" pitchFamily="34" charset="0"/>
-                <a:ea typeface="Microsoft YaHei" pitchFamily="34" charset="-122"/>
-                <a:cs typeface="Microsoft YaHei" pitchFamily="34" charset="-120"/>
-              </a:rPr>
-              <a:t>Batching 提升吞吐，但本质上是在吞吐和单请求延迟之间做权衡。</a:t>
-            </a:r>
-            <a:endParaRPr lang="en-US" sz="1070" dirty="0"/>
+            <a:pPr algn="l" indent="0" marL="0">
+              <a:buNone/>
+            </a:pPr>
+            <a:r>
+              <a:rPr lang="en-US" sz="1020" b="1" dirty="0">
+                <a:solidFill>
+                  <a:srgbClr val="1F1F1F"/>
+                </a:solidFill>
+                <a:latin typeface="Microsoft YaHei" pitchFamily="34" charset="0"/>
+                <a:ea typeface="Microsoft YaHei" pitchFamily="34" charset="-122"/>
+                <a:cs typeface="Microsoft YaHei" pitchFamily="34" charset="-120"/>
+              </a:rPr>
+              <a:t>Batching 通常提升吞吐，同时会带来单请求延迟权衡。</a:t>
+            </a:r>
+            <a:endParaRPr lang="en-US" sz="1020" dirty="0"/>
           </a:p>
         </p:txBody>
       </p:sp>
@@ -6519,11 +6615,11 @@
             </a:avLst>
           </a:prstGeom>
           <a:solidFill>
-            <a:srgbClr val="FFF1F2"/>
-          </a:solidFill>
-          <a:ln w="10160">
-            <a:solidFill>
-              <a:srgbClr val="F2C7CB"/>
+            <a:srgbClr val="FFFFFF"/>
+          </a:solidFill>
+          <a:ln w="9525">
+            <a:solidFill>
+              <a:srgbClr val="DCDCDC"/>
             </a:solidFill>
             <a:prstDash val="solid"/>
           </a:ln>
@@ -6538,7 +6634,7 @@
         <p:spPr>
           <a:xfrm>
             <a:off x="804672" y="5650992"/>
-            <a:ext cx="100584" cy="493776"/>
+            <a:ext cx="91440" cy="493776"/>
           </a:xfrm>
           <a:prstGeom prst="rect">
             <a:avLst/>
@@ -6562,8 +6658,47 @@
         </p:nvSpPr>
         <p:spPr>
           <a:xfrm>
-            <a:off x="1078992" y="5815584"/>
-            <a:ext cx="9921240" cy="118872"/>
+            <a:off x="1051560" y="5760720"/>
+            <a:ext cx="713232" cy="91440"/>
+          </a:xfrm>
+          <a:prstGeom prst="rect">
+            <a:avLst/>
+          </a:prstGeom>
+          <a:noFill/>
+          <a:ln/>
+        </p:spPr>
+        <p:txBody>
+          <a:bodyPr wrap="square" lIns="0" tIns="0" rIns="0" bIns="0" rtlCol="0" anchor="ctr"/>
+          <a:lstStyle/>
+          <a:p>
+            <a:pPr indent="0" marL="0">
+              <a:buNone/>
+            </a:pPr>
+            <a:r>
+              <a:rPr lang="en-US" sz="720" b="1" dirty="0">
+                <a:solidFill>
+                  <a:srgbClr val="C7000B"/>
+                </a:solidFill>
+                <a:latin typeface="Microsoft YaHei" pitchFamily="34" charset="0"/>
+                <a:ea typeface="Microsoft YaHei" pitchFamily="34" charset="-122"/>
+                <a:cs typeface="Microsoft YaHei" pitchFamily="34" charset="-120"/>
+              </a:rPr>
+              <a:t>本页要点</a:t>
+            </a:r>
+            <a:endParaRPr lang="en-US" sz="720" dirty="0"/>
+          </a:p>
+        </p:txBody>
+      </p:sp>
+      <p:sp>
+        <p:nvSpPr>
+          <p:cNvPr id="41" name="Text 39"/>
+          <p:cNvSpPr/>
+          <p:nvPr/>
+        </p:nvSpPr>
+        <p:spPr>
+          <a:xfrm>
+            <a:off x="1874520" y="5815584"/>
+            <a:ext cx="9006840" cy="118872"/>
           </a:xfrm>
           <a:prstGeom prst="rect">
             <a:avLst/>
@@ -6577,21 +6712,21 @@
           </a:bodyPr>
           <a:lstStyle/>
           <a:p>
-            <a:pPr algn="ctr" indent="0" marL="0">
-              <a:buNone/>
-            </a:pPr>
-            <a:r>
-              <a:rPr lang="en-US" sz="1070" b="1" dirty="0">
-                <a:solidFill>
-                  <a:srgbClr val="C7000B"/>
-                </a:solidFill>
-                <a:latin typeface="Microsoft YaHei" pitchFamily="34" charset="0"/>
-                <a:ea typeface="Microsoft YaHei" pitchFamily="34" charset="-122"/>
-                <a:cs typeface="Microsoft YaHei" pitchFamily="34" charset="-120"/>
-              </a:rPr>
-              <a:t>量化可以显著省显存，但上线前必须用业务数据验证效果损失。</a:t>
-            </a:r>
-            <a:endParaRPr lang="en-US" sz="1070" dirty="0"/>
+            <a:pPr algn="l" indent="0" marL="0">
+              <a:buNone/>
+            </a:pPr>
+            <a:r>
+              <a:rPr lang="en-US" sz="1020" b="1" dirty="0">
+                <a:solidFill>
+                  <a:srgbClr val="1F1F1F"/>
+                </a:solidFill>
+                <a:latin typeface="Microsoft YaHei" pitchFamily="34" charset="0"/>
+                <a:ea typeface="Microsoft YaHei" pitchFamily="34" charset="-122"/>
+                <a:cs typeface="Microsoft YaHei" pitchFamily="34" charset="-120"/>
+              </a:rPr>
+              <a:t>量化收益需要结合业务数据验证效果损失。</a:t>
+            </a:r>
+            <a:endParaRPr lang="en-US" sz="1020" dirty="0"/>
           </a:p>
         </p:txBody>
       </p:sp>
@@ -6918,7 +7053,7 @@
                 <a:ea typeface="Microsoft YaHei" pitchFamily="34" charset="-122"/>
                 <a:cs typeface="Microsoft YaHei" pitchFamily="34" charset="-120"/>
               </a:rPr>
-              <a:t>推理框架的价值不只是“跑模型”，而是把调度、缓存、算子和分布式能力集成起来。</a:t>
+              <a:t>推理框架把调度、缓存、算子和分布式能力集成到一套服务化系统里。</a:t>
             </a:r>
             <a:endParaRPr lang="en-US" sz="1080" dirty="0"/>
           </a:p>
@@ -6973,12 +7108,12 @@
         </p:nvSpPr>
         <p:spPr>
           <a:xfrm>
-            <a:off x="4663440" y="2240280"/>
-            <a:ext cx="1965960" cy="1051560"/>
+            <a:off x="4617720" y="2487168"/>
+            <a:ext cx="2176272" cy="914400"/>
           </a:xfrm>
           <a:prstGeom prst="roundRect">
             <a:avLst>
-              <a:gd name="adj" fmla="val 3913"/>
+              <a:gd name="adj" fmla="val 4500"/>
             </a:avLst>
           </a:prstGeom>
           <a:solidFill>
@@ -7000,8 +7135,8 @@
         </p:nvSpPr>
         <p:spPr>
           <a:xfrm>
-            <a:off x="4983480" y="2514600"/>
-            <a:ext cx="1325880" cy="292608"/>
+            <a:off x="4956048" y="2724912"/>
+            <a:ext cx="1481328" cy="274320"/>
           </a:xfrm>
           <a:prstGeom prst="rect">
             <a:avLst/>
@@ -7017,7 +7152,7 @@
               <a:buNone/>
             </a:pPr>
             <a:r>
-              <a:rPr lang="en-US" sz="1400" b="1" dirty="0">
+              <a:rPr lang="en-US" sz="1350" b="1" dirty="0">
                 <a:solidFill>
                   <a:srgbClr val="FFFFFF"/>
                 </a:solidFill>
@@ -7027,14 +7162,14 @@
               </a:rPr>
               <a:t>Inference</a:t>
             </a:r>
-            <a:endParaRPr lang="en-US" sz="1400" dirty="0"/>
+            <a:endParaRPr lang="en-US" sz="1350" dirty="0"/>
           </a:p>
           <a:p>
             <a:pPr algn="ctr" indent="0" marL="0">
               <a:buNone/>
             </a:pPr>
             <a:r>
-              <a:rPr lang="en-US" sz="1400" b="1" dirty="0">
+              <a:rPr lang="en-US" sz="1350" b="1" dirty="0">
                 <a:solidFill>
                   <a:srgbClr val="FFFFFF"/>
                 </a:solidFill>
@@ -7044,7 +7179,7 @@
               </a:rPr>
               <a:t>Engine</a:t>
             </a:r>
-            <a:endParaRPr lang="en-US" sz="1400" dirty="0"/>
+            <a:endParaRPr lang="en-US" sz="1350" dirty="0"/>
           </a:p>
         </p:txBody>
       </p:sp>
@@ -7056,7 +7191,7 @@
         </p:nvSpPr>
         <p:spPr>
           <a:xfrm>
-            <a:off x="914400" y="2148840"/>
+            <a:off x="914400" y="2084832"/>
             <a:ext cx="2468880" cy="786384"/>
           </a:xfrm>
           <a:prstGeom prst="roundRect">
@@ -7083,7 +7218,7 @@
         </p:nvSpPr>
         <p:spPr>
           <a:xfrm>
-            <a:off x="914400" y="2148840"/>
+            <a:off x="914400" y="2084832"/>
             <a:ext cx="73152" cy="786384"/>
           </a:xfrm>
           <a:prstGeom prst="rect">
@@ -7108,7 +7243,7 @@
         </p:nvSpPr>
         <p:spPr>
           <a:xfrm>
-            <a:off x="1115568" y="2276856"/>
+            <a:off x="1115568" y="2212848"/>
             <a:ext cx="2176272" cy="164592"/>
           </a:xfrm>
           <a:prstGeom prst="rect">
@@ -7149,7 +7284,7 @@
         </p:nvSpPr>
         <p:spPr>
           <a:xfrm>
-            <a:off x="1115568" y="2532888"/>
+            <a:off x="1115568" y="2468880"/>
             <a:ext cx="2176272" cy="347472"/>
           </a:xfrm>
           <a:prstGeom prst="rect">
@@ -7190,8 +7325,8 @@
         </p:nvSpPr>
         <p:spPr>
           <a:xfrm>
-            <a:off x="3429000" y="2542032"/>
-            <a:ext cx="1188720" cy="219456"/>
+            <a:off x="3383280" y="2478024"/>
+            <a:ext cx="1188720" cy="265176"/>
           </a:xfrm>
           <a:prstGeom prst="line">
             <a:avLst/>
@@ -7215,7 +7350,7 @@
         </p:nvSpPr>
         <p:spPr>
           <a:xfrm>
-            <a:off x="8092440" y="2148840"/>
+            <a:off x="8092440" y="2084832"/>
             <a:ext cx="2468880" cy="786384"/>
           </a:xfrm>
           <a:prstGeom prst="roundRect">
@@ -7242,7 +7377,7 @@
         </p:nvSpPr>
         <p:spPr>
           <a:xfrm>
-            <a:off x="8092440" y="2148840"/>
+            <a:off x="8092440" y="2084832"/>
             <a:ext cx="73152" cy="786384"/>
           </a:xfrm>
           <a:prstGeom prst="rect">
@@ -7267,7 +7402,7 @@
         </p:nvSpPr>
         <p:spPr>
           <a:xfrm>
-            <a:off x="8293608" y="2276856"/>
+            <a:off x="8293608" y="2212848"/>
             <a:ext cx="2176272" cy="164592"/>
           </a:xfrm>
           <a:prstGeom prst="rect">
@@ -7308,7 +7443,7 @@
         </p:nvSpPr>
         <p:spPr>
           <a:xfrm>
-            <a:off x="8293608" y="2532888"/>
+            <a:off x="8293608" y="2468880"/>
             <a:ext cx="2176272" cy="347472"/>
           </a:xfrm>
           <a:prstGeom prst="rect">
@@ -7349,8 +7484,8 @@
         </p:nvSpPr>
         <p:spPr>
           <a:xfrm>
-            <a:off x="7909560" y="2542032"/>
-            <a:ext cx="-1188720" cy="219456"/>
+            <a:off x="8092440" y="2478024"/>
+            <a:ext cx="-1252728" cy="265176"/>
           </a:xfrm>
           <a:prstGeom prst="line">
             <a:avLst/>
@@ -7374,7 +7509,7 @@
         </p:nvSpPr>
         <p:spPr>
           <a:xfrm>
-            <a:off x="914400" y="3520440"/>
+            <a:off x="914400" y="3675888"/>
             <a:ext cx="2468880" cy="786384"/>
           </a:xfrm>
           <a:prstGeom prst="roundRect">
@@ -7401,7 +7536,7 @@
         </p:nvSpPr>
         <p:spPr>
           <a:xfrm>
-            <a:off x="914400" y="3520440"/>
+            <a:off x="914400" y="3675888"/>
             <a:ext cx="73152" cy="786384"/>
           </a:xfrm>
           <a:prstGeom prst="rect">
@@ -7426,7 +7561,7 @@
         </p:nvSpPr>
         <p:spPr>
           <a:xfrm>
-            <a:off x="1115568" y="3648456"/>
+            <a:off x="1115568" y="3803904"/>
             <a:ext cx="2176272" cy="164592"/>
           </a:xfrm>
           <a:prstGeom prst="rect">
@@ -7467,7 +7602,7 @@
         </p:nvSpPr>
         <p:spPr>
           <a:xfrm>
-            <a:off x="1115568" y="3904488"/>
+            <a:off x="1115568" y="4059936"/>
             <a:ext cx="2176272" cy="347472"/>
           </a:xfrm>
           <a:prstGeom prst="rect">
@@ -7508,8 +7643,8 @@
         </p:nvSpPr>
         <p:spPr>
           <a:xfrm>
-            <a:off x="3429000" y="3913632"/>
-            <a:ext cx="1188720" cy="-1152144"/>
+            <a:off x="3383280" y="4069080"/>
+            <a:ext cx="1188720" cy="-914400"/>
           </a:xfrm>
           <a:prstGeom prst="line">
             <a:avLst/>
@@ -7533,7 +7668,7 @@
         </p:nvSpPr>
         <p:spPr>
           <a:xfrm>
-            <a:off x="8092440" y="3520440"/>
+            <a:off x="8092440" y="3675888"/>
             <a:ext cx="2468880" cy="786384"/>
           </a:xfrm>
           <a:prstGeom prst="roundRect">
@@ -7560,7 +7695,7 @@
         </p:nvSpPr>
         <p:spPr>
           <a:xfrm>
-            <a:off x="8092440" y="3520440"/>
+            <a:off x="8092440" y="3675888"/>
             <a:ext cx="73152" cy="786384"/>
           </a:xfrm>
           <a:prstGeom prst="rect">
@@ -7585,7 +7720,7 @@
         </p:nvSpPr>
         <p:spPr>
           <a:xfrm>
-            <a:off x="8293608" y="3648456"/>
+            <a:off x="8293608" y="3803904"/>
             <a:ext cx="2176272" cy="164592"/>
           </a:xfrm>
           <a:prstGeom prst="rect">
@@ -7626,7 +7761,7 @@
         </p:nvSpPr>
         <p:spPr>
           <a:xfrm>
-            <a:off x="8293608" y="3904488"/>
+            <a:off x="8293608" y="4059936"/>
             <a:ext cx="2176272" cy="347472"/>
           </a:xfrm>
           <a:prstGeom prst="rect">
@@ -7667,8 +7802,8 @@
         </p:nvSpPr>
         <p:spPr>
           <a:xfrm>
-            <a:off x="7909560" y="3913632"/>
-            <a:ext cx="-1188720" cy="-1152144"/>
+            <a:off x="8092440" y="4069080"/>
+            <a:ext cx="-1252728" cy="-914400"/>
           </a:xfrm>
           <a:prstGeom prst="line">
             <a:avLst/>
@@ -8401,11 +8536,11 @@
             </a:avLst>
           </a:prstGeom>
           <a:solidFill>
-            <a:srgbClr val="FFF1F2"/>
-          </a:solidFill>
-          <a:ln w="10160">
-            <a:solidFill>
-              <a:srgbClr val="F2C7CB"/>
+            <a:srgbClr val="FFFFFF"/>
+          </a:solidFill>
+          <a:ln w="9525">
+            <a:solidFill>
+              <a:srgbClr val="DCDCDC"/>
             </a:solidFill>
             <a:prstDash val="solid"/>
           </a:ln>
@@ -8420,7 +8555,7 @@
         <p:spPr>
           <a:xfrm>
             <a:off x="804672" y="5650992"/>
-            <a:ext cx="100584" cy="493776"/>
+            <a:ext cx="91440" cy="493776"/>
           </a:xfrm>
           <a:prstGeom prst="rect">
             <a:avLst/>
@@ -8444,8 +8579,47 @@
         </p:nvSpPr>
         <p:spPr>
           <a:xfrm>
-            <a:off x="1078992" y="5815584"/>
-            <a:ext cx="9921240" cy="118872"/>
+            <a:off x="1051560" y="5760720"/>
+            <a:ext cx="713232" cy="91440"/>
+          </a:xfrm>
+          <a:prstGeom prst="rect">
+            <a:avLst/>
+          </a:prstGeom>
+          <a:noFill/>
+          <a:ln/>
+        </p:spPr>
+        <p:txBody>
+          <a:bodyPr wrap="square" lIns="0" tIns="0" rIns="0" bIns="0" rtlCol="0" anchor="ctr"/>
+          <a:lstStyle/>
+          <a:p>
+            <a:pPr indent="0" marL="0">
+              <a:buNone/>
+            </a:pPr>
+            <a:r>
+              <a:rPr lang="en-US" sz="720" b="1" dirty="0">
+                <a:solidFill>
+                  <a:srgbClr val="C7000B"/>
+                </a:solidFill>
+                <a:latin typeface="Microsoft YaHei" pitchFamily="34" charset="0"/>
+                <a:ea typeface="Microsoft YaHei" pitchFamily="34" charset="-122"/>
+                <a:cs typeface="Microsoft YaHei" pitchFamily="34" charset="-120"/>
+              </a:rPr>
+              <a:t>本页要点</a:t>
+            </a:r>
+            <a:endParaRPr lang="en-US" sz="720" dirty="0"/>
+          </a:p>
+        </p:txBody>
+      </p:sp>
+      <p:sp>
+        <p:nvSpPr>
+          <p:cNvPr id="57" name="Text 55"/>
+          <p:cNvSpPr/>
+          <p:nvPr/>
+        </p:nvSpPr>
+        <p:spPr>
+          <a:xfrm>
+            <a:off x="1874520" y="5815584"/>
+            <a:ext cx="9006840" cy="118872"/>
           </a:xfrm>
           <a:prstGeom prst="rect">
             <a:avLst/>
@@ -8459,21 +8633,21 @@
           </a:bodyPr>
           <a:lstStyle/>
           <a:p>
-            <a:pPr algn="ctr" indent="0" marL="0">
-              <a:buNone/>
-            </a:pPr>
-            <a:r>
-              <a:rPr lang="en-US" sz="1070" b="1" dirty="0">
-                <a:solidFill>
-                  <a:srgbClr val="C7000B"/>
-                </a:solidFill>
-                <a:latin typeface="Microsoft YaHei" pitchFamily="34" charset="0"/>
-                <a:ea typeface="Microsoft YaHei" pitchFamily="34" charset="-122"/>
-                <a:cs typeface="Microsoft YaHei" pitchFamily="34" charset="-120"/>
-              </a:rPr>
-              <a:t>推理框架选型要看业务目标和硬件栈，不只是看哪个 benchmark 更高。</a:t>
-            </a:r>
-            <a:endParaRPr lang="en-US" sz="1070" dirty="0"/>
+            <a:pPr algn="l" indent="0" marL="0">
+              <a:buNone/>
+            </a:pPr>
+            <a:r>
+              <a:rPr lang="en-US" sz="1020" b="1" dirty="0">
+                <a:solidFill>
+                  <a:srgbClr val="1F1F1F"/>
+                </a:solidFill>
+                <a:latin typeface="Microsoft YaHei" pitchFamily="34" charset="0"/>
+                <a:ea typeface="Microsoft YaHei" pitchFamily="34" charset="-122"/>
+                <a:cs typeface="Microsoft YaHei" pitchFamily="34" charset="-120"/>
+              </a:rPr>
+              <a:t>推理框架选型通常同时看业务目标、模型支持、硬件栈和运维成本。</a:t>
+            </a:r>
+            <a:endParaRPr lang="en-US" sz="1020" dirty="0"/>
           </a:p>
         </p:txBody>
       </p:sp>
@@ -8841,7 +9015,7 @@
                 <a:ea typeface="Microsoft YaHei" pitchFamily="34" charset="-122"/>
                 <a:cs typeface="Microsoft YaHei" pitchFamily="34" charset="-120"/>
               </a:rPr>
-              <a:t>多卡多机不是简单堆 GPU，通信开销会改变瓶颈位置。</a:t>
+              <a:t>多卡多机会提升容量，也会把通信开销带进推理链路。</a:t>
             </a:r>
             <a:endParaRPr lang="en-US" sz="1320" dirty="0"/>
           </a:p>
@@ -10252,11 +10426,11 @@
             </a:avLst>
           </a:prstGeom>
           <a:solidFill>
-            <a:srgbClr val="FFF1F2"/>
-          </a:solidFill>
-          <a:ln w="10160">
-            <a:solidFill>
-              <a:srgbClr val="F2C7CB"/>
+            <a:srgbClr val="FFFFFF"/>
+          </a:solidFill>
+          <a:ln w="9525">
+            <a:solidFill>
+              <a:srgbClr val="DCDCDC"/>
             </a:solidFill>
             <a:prstDash val="solid"/>
           </a:ln>
@@ -10271,7 +10445,7 @@
         <p:spPr>
           <a:xfrm>
             <a:off x="804672" y="5650992"/>
-            <a:ext cx="100584" cy="493776"/>
+            <a:ext cx="91440" cy="493776"/>
           </a:xfrm>
           <a:prstGeom prst="rect">
             <a:avLst/>
@@ -10295,8 +10469,47 @@
         </p:nvSpPr>
         <p:spPr>
           <a:xfrm>
-            <a:off x="1078992" y="5815584"/>
-            <a:ext cx="9921240" cy="118872"/>
+            <a:off x="1051560" y="5760720"/>
+            <a:ext cx="713232" cy="91440"/>
+          </a:xfrm>
+          <a:prstGeom prst="rect">
+            <a:avLst/>
+          </a:prstGeom>
+          <a:noFill/>
+          <a:ln/>
+        </p:spPr>
+        <p:txBody>
+          <a:bodyPr wrap="square" lIns="0" tIns="0" rIns="0" bIns="0" rtlCol="0" anchor="ctr"/>
+          <a:lstStyle/>
+          <a:p>
+            <a:pPr indent="0" marL="0">
+              <a:buNone/>
+            </a:pPr>
+            <a:r>
+              <a:rPr lang="en-US" sz="720" b="1" dirty="0">
+                <a:solidFill>
+                  <a:srgbClr val="C7000B"/>
+                </a:solidFill>
+                <a:latin typeface="Microsoft YaHei" pitchFamily="34" charset="0"/>
+                <a:ea typeface="Microsoft YaHei" pitchFamily="34" charset="-122"/>
+                <a:cs typeface="Microsoft YaHei" pitchFamily="34" charset="-120"/>
+              </a:rPr>
+              <a:t>本页要点</a:t>
+            </a:r>
+            <a:endParaRPr lang="en-US" sz="720" dirty="0"/>
+          </a:p>
+        </p:txBody>
+      </p:sp>
+      <p:sp>
+        <p:nvSpPr>
+          <p:cNvPr id="59" name="Text 57"/>
+          <p:cNvSpPr/>
+          <p:nvPr/>
+        </p:nvSpPr>
+        <p:spPr>
+          <a:xfrm>
+            <a:off x="1874520" y="5815584"/>
+            <a:ext cx="9006840" cy="118872"/>
           </a:xfrm>
           <a:prstGeom prst="rect">
             <a:avLst/>
@@ -10310,21 +10523,21 @@
           </a:bodyPr>
           <a:lstStyle/>
           <a:p>
-            <a:pPr algn="ctr" indent="0" marL="0">
-              <a:buNone/>
-            </a:pPr>
-            <a:r>
-              <a:rPr lang="en-US" sz="1070" b="1" dirty="0">
-                <a:solidFill>
-                  <a:srgbClr val="C7000B"/>
-                </a:solidFill>
-                <a:latin typeface="Microsoft YaHei" pitchFamily="34" charset="0"/>
-                <a:ea typeface="Microsoft YaHei" pitchFamily="34" charset="-122"/>
-                <a:cs typeface="Microsoft YaHei" pitchFamily="34" charset="-120"/>
-              </a:rPr>
-              <a:t>多卡解决容量问题，但会引入通信税和运维复杂度。</a:t>
-            </a:r>
-            <a:endParaRPr lang="en-US" sz="1070" dirty="0"/>
+            <a:pPr algn="l" indent="0" marL="0">
+              <a:buNone/>
+            </a:pPr>
+            <a:r>
+              <a:rPr lang="en-US" sz="1020" b="1" dirty="0">
+                <a:solidFill>
+                  <a:srgbClr val="1F1F1F"/>
+                </a:solidFill>
+                <a:latin typeface="Microsoft YaHei" pitchFamily="34" charset="0"/>
+                <a:ea typeface="Microsoft YaHei" pitchFamily="34" charset="-122"/>
+                <a:cs typeface="Microsoft YaHei" pitchFamily="34" charset="-120"/>
+              </a:rPr>
+              <a:t>多卡部署提升容量，同时需要关注通信、同步和故障恢复。</a:t>
+            </a:r>
+            <a:endParaRPr lang="en-US" sz="1020" dirty="0"/>
           </a:p>
         </p:txBody>
       </p:sp>
@@ -11829,11 +12042,11 @@
             </a:avLst>
           </a:prstGeom>
           <a:solidFill>
-            <a:srgbClr val="FFF1F2"/>
-          </a:solidFill>
-          <a:ln w="10160">
-            <a:solidFill>
-              <a:srgbClr val="F2C7CB"/>
+            <a:srgbClr val="FFFFFF"/>
+          </a:solidFill>
+          <a:ln w="9525">
+            <a:solidFill>
+              <a:srgbClr val="DCDCDC"/>
             </a:solidFill>
             <a:prstDash val="solid"/>
           </a:ln>
@@ -11848,7 +12061,7 @@
         <p:spPr>
           <a:xfrm>
             <a:off x="804672" y="5650992"/>
-            <a:ext cx="100584" cy="493776"/>
+            <a:ext cx="91440" cy="493776"/>
           </a:xfrm>
           <a:prstGeom prst="rect">
             <a:avLst/>
@@ -11872,8 +12085,47 @@
         </p:nvSpPr>
         <p:spPr>
           <a:xfrm>
-            <a:off x="1078992" y="5815584"/>
-            <a:ext cx="9921240" cy="118872"/>
+            <a:off x="1051560" y="5760720"/>
+            <a:ext cx="713232" cy="91440"/>
+          </a:xfrm>
+          <a:prstGeom prst="rect">
+            <a:avLst/>
+          </a:prstGeom>
+          <a:noFill/>
+          <a:ln/>
+        </p:spPr>
+        <p:txBody>
+          <a:bodyPr wrap="square" lIns="0" tIns="0" rIns="0" bIns="0" rtlCol="0" anchor="ctr"/>
+          <a:lstStyle/>
+          <a:p>
+            <a:pPr indent="0" marL="0">
+              <a:buNone/>
+            </a:pPr>
+            <a:r>
+              <a:rPr lang="en-US" sz="720" b="1" dirty="0">
+                <a:solidFill>
+                  <a:srgbClr val="C7000B"/>
+                </a:solidFill>
+                <a:latin typeface="Microsoft YaHei" pitchFamily="34" charset="0"/>
+                <a:ea typeface="Microsoft YaHei" pitchFamily="34" charset="-122"/>
+                <a:cs typeface="Microsoft YaHei" pitchFamily="34" charset="-120"/>
+              </a:rPr>
+              <a:t>本页要点</a:t>
+            </a:r>
+            <a:endParaRPr lang="en-US" sz="720" dirty="0"/>
+          </a:p>
+        </p:txBody>
+      </p:sp>
+      <p:sp>
+        <p:nvSpPr>
+          <p:cNvPr id="45" name="Text 43"/>
+          <p:cNvSpPr/>
+          <p:nvPr/>
+        </p:nvSpPr>
+        <p:spPr>
+          <a:xfrm>
+            <a:off x="1874520" y="5815584"/>
+            <a:ext cx="9006840" cy="118872"/>
           </a:xfrm>
           <a:prstGeom prst="rect">
             <a:avLst/>
@@ -11887,21 +12139,21 @@
           </a:bodyPr>
           <a:lstStyle/>
           <a:p>
-            <a:pPr algn="ctr" indent="0" marL="0">
-              <a:buNone/>
-            </a:pPr>
-            <a:r>
-              <a:rPr lang="en-US" sz="1070" b="1" dirty="0">
-                <a:solidFill>
-                  <a:srgbClr val="C7000B"/>
-                </a:solidFill>
-                <a:latin typeface="Microsoft YaHei" pitchFamily="34" charset="0"/>
-                <a:ea typeface="Microsoft YaHei" pitchFamily="34" charset="-122"/>
-                <a:cs typeface="Microsoft YaHei" pitchFamily="34" charset="-120"/>
-              </a:rPr>
-              <a:t>推理优化的核心，是在体验、吞吐和成本之间做工程取舍。</a:t>
-            </a:r>
-            <a:endParaRPr lang="en-US" sz="1070" dirty="0"/>
+            <a:pPr algn="l" indent="0" marL="0">
+              <a:buNone/>
+            </a:pPr>
+            <a:r>
+              <a:rPr lang="en-US" sz="1020" b="1" dirty="0">
+                <a:solidFill>
+                  <a:srgbClr val="1F1F1F"/>
+                </a:solidFill>
+                <a:latin typeface="Microsoft YaHei" pitchFamily="34" charset="0"/>
+                <a:ea typeface="Microsoft YaHei" pitchFamily="34" charset="-122"/>
+                <a:cs typeface="Microsoft YaHei" pitchFamily="34" charset="-120"/>
+              </a:rPr>
+              <a:t>推理优化通常围绕体验、吞吐和成本做平衡。</a:t>
+            </a:r>
+            <a:endParaRPr lang="en-US" sz="1020" dirty="0"/>
           </a:p>
         </p:txBody>
       </p:sp>
@@ -12873,11 +13125,11 @@
             </a:avLst>
           </a:prstGeom>
           <a:solidFill>
-            <a:srgbClr val="FFF1F2"/>
-          </a:solidFill>
-          <a:ln w="10160">
-            <a:solidFill>
-              <a:srgbClr val="F2C7CB"/>
+            <a:srgbClr val="FFFFFF"/>
+          </a:solidFill>
+          <a:ln w="9525">
+            <a:solidFill>
+              <a:srgbClr val="DCDCDC"/>
             </a:solidFill>
             <a:prstDash val="solid"/>
           </a:ln>
@@ -12892,7 +13144,7 @@
         <p:spPr>
           <a:xfrm>
             <a:off x="804672" y="5522976"/>
-            <a:ext cx="100584" cy="493776"/>
+            <a:ext cx="91440" cy="493776"/>
           </a:xfrm>
           <a:prstGeom prst="rect">
             <a:avLst/>
@@ -12916,8 +13168,47 @@
         </p:nvSpPr>
         <p:spPr>
           <a:xfrm>
-            <a:off x="1078992" y="5687568"/>
-            <a:ext cx="9921240" cy="118872"/>
+            <a:off x="1051560" y="5632704"/>
+            <a:ext cx="713232" cy="91440"/>
+          </a:xfrm>
+          <a:prstGeom prst="rect">
+            <a:avLst/>
+          </a:prstGeom>
+          <a:noFill/>
+          <a:ln/>
+        </p:spPr>
+        <p:txBody>
+          <a:bodyPr wrap="square" lIns="0" tIns="0" rIns="0" bIns="0" rtlCol="0" anchor="ctr"/>
+          <a:lstStyle/>
+          <a:p>
+            <a:pPr indent="0" marL="0">
+              <a:buNone/>
+            </a:pPr>
+            <a:r>
+              <a:rPr lang="en-US" sz="720" b="1" dirty="0">
+                <a:solidFill>
+                  <a:srgbClr val="C7000B"/>
+                </a:solidFill>
+                <a:latin typeface="Microsoft YaHei" pitchFamily="34" charset="0"/>
+                <a:ea typeface="Microsoft YaHei" pitchFamily="34" charset="-122"/>
+                <a:cs typeface="Microsoft YaHei" pitchFamily="34" charset="-120"/>
+              </a:rPr>
+              <a:t>本页要点</a:t>
+            </a:r>
+            <a:endParaRPr lang="en-US" sz="720" dirty="0"/>
+          </a:p>
+        </p:txBody>
+      </p:sp>
+      <p:sp>
+        <p:nvSpPr>
+          <p:cNvPr id="32" name="Text 30"/>
+          <p:cNvSpPr/>
+          <p:nvPr/>
+        </p:nvSpPr>
+        <p:spPr>
+          <a:xfrm>
+            <a:off x="1874520" y="5687568"/>
+            <a:ext cx="9006840" cy="118872"/>
           </a:xfrm>
           <a:prstGeom prst="rect">
             <a:avLst/>
@@ -12931,21 +13222,21 @@
           </a:bodyPr>
           <a:lstStyle/>
           <a:p>
-            <a:pPr algn="ctr" indent="0" marL="0">
-              <a:buNone/>
-            </a:pPr>
-            <a:r>
-              <a:rPr lang="en-US" sz="1070" b="1" dirty="0">
-                <a:solidFill>
-                  <a:srgbClr val="C7000B"/>
-                </a:solidFill>
-                <a:latin typeface="Microsoft YaHei" pitchFamily="34" charset="0"/>
-                <a:ea typeface="Microsoft YaHei" pitchFamily="34" charset="-122"/>
-                <a:cs typeface="Microsoft YaHei" pitchFamily="34" charset="-120"/>
-              </a:rPr>
-              <a:t>理解推理，不是为了记术语，而是为了判断慢在哪里、贵在哪里、该优化哪里。</a:t>
-            </a:r>
-            <a:endParaRPr lang="en-US" sz="1070" dirty="0"/>
+            <a:pPr algn="l" indent="0" marL="0">
+              <a:buNone/>
+            </a:pPr>
+            <a:r>
+              <a:rPr lang="en-US" sz="1020" b="1" dirty="0">
+                <a:solidFill>
+                  <a:srgbClr val="1F1F1F"/>
+                </a:solidFill>
+                <a:latin typeface="Microsoft YaHei" pitchFamily="34" charset="0"/>
+                <a:ea typeface="Microsoft YaHei" pitchFamily="34" charset="-122"/>
+                <a:cs typeface="Microsoft YaHei" pitchFamily="34" charset="-120"/>
+              </a:rPr>
+              <a:t>推理指标能帮助定位慢点、成本来源和优化方向。</a:t>
+            </a:r>
+            <a:endParaRPr lang="en-US" sz="1020" dirty="0"/>
           </a:p>
         </p:txBody>
       </p:sp>
@@ -14082,11 +14373,11 @@
             </a:avLst>
           </a:prstGeom>
           <a:solidFill>
-            <a:srgbClr val="FFF1F2"/>
-          </a:solidFill>
-          <a:ln w="10160">
-            <a:solidFill>
-              <a:srgbClr val="F2C7CB"/>
+            <a:srgbClr val="FFFFFF"/>
+          </a:solidFill>
+          <a:ln w="9525">
+            <a:solidFill>
+              <a:srgbClr val="DCDCDC"/>
             </a:solidFill>
             <a:prstDash val="solid"/>
           </a:ln>
@@ -14101,7 +14392,7 @@
         <p:spPr>
           <a:xfrm>
             <a:off x="804672" y="5522976"/>
-            <a:ext cx="100584" cy="493776"/>
+            <a:ext cx="91440" cy="493776"/>
           </a:xfrm>
           <a:prstGeom prst="rect">
             <a:avLst/>
@@ -14125,8 +14416,47 @@
         </p:nvSpPr>
         <p:spPr>
           <a:xfrm>
-            <a:off x="1078992" y="5687568"/>
-            <a:ext cx="9921240" cy="118872"/>
+            <a:off x="1051560" y="5632704"/>
+            <a:ext cx="713232" cy="91440"/>
+          </a:xfrm>
+          <a:prstGeom prst="rect">
+            <a:avLst/>
+          </a:prstGeom>
+          <a:noFill/>
+          <a:ln/>
+        </p:spPr>
+        <p:txBody>
+          <a:bodyPr wrap="square" lIns="0" tIns="0" rIns="0" bIns="0" rtlCol="0" anchor="ctr"/>
+          <a:lstStyle/>
+          <a:p>
+            <a:pPr indent="0" marL="0">
+              <a:buNone/>
+            </a:pPr>
+            <a:r>
+              <a:rPr lang="en-US" sz="720" b="1" dirty="0">
+                <a:solidFill>
+                  <a:srgbClr val="C7000B"/>
+                </a:solidFill>
+                <a:latin typeface="Microsoft YaHei" pitchFamily="34" charset="0"/>
+                <a:ea typeface="Microsoft YaHei" pitchFamily="34" charset="-122"/>
+                <a:cs typeface="Microsoft YaHei" pitchFamily="34" charset="-120"/>
+              </a:rPr>
+              <a:t>本页要点</a:t>
+            </a:r>
+            <a:endParaRPr lang="en-US" sz="720" dirty="0"/>
+          </a:p>
+        </p:txBody>
+      </p:sp>
+      <p:sp>
+        <p:nvSpPr>
+          <p:cNvPr id="35" name="Text 33"/>
+          <p:cNvSpPr/>
+          <p:nvPr/>
+        </p:nvSpPr>
+        <p:spPr>
+          <a:xfrm>
+            <a:off x="1874520" y="5687568"/>
+            <a:ext cx="9006840" cy="118872"/>
           </a:xfrm>
           <a:prstGeom prst="rect">
             <a:avLst/>
@@ -14140,21 +14470,21 @@
           </a:bodyPr>
           <a:lstStyle/>
           <a:p>
-            <a:pPr algn="ctr" indent="0" marL="0">
-              <a:buNone/>
-            </a:pPr>
-            <a:r>
-              <a:rPr lang="en-US" sz="1070" b="1" dirty="0">
-                <a:solidFill>
-                  <a:srgbClr val="C7000B"/>
-                </a:solidFill>
-                <a:latin typeface="Microsoft YaHei" pitchFamily="34" charset="0"/>
-                <a:ea typeface="Microsoft YaHei" pitchFamily="34" charset="-122"/>
-                <a:cs typeface="Microsoft YaHei" pitchFamily="34" charset="-120"/>
-              </a:rPr>
-              <a:t>推理更像线上系统工程：既要算得准，也要算得快、扛得住、成本可控。</a:t>
-            </a:r>
-            <a:endParaRPr lang="en-US" sz="1070" dirty="0"/>
+            <a:pPr algn="l" indent="0" marL="0">
+              <a:buNone/>
+            </a:pPr>
+            <a:r>
+              <a:rPr lang="en-US" sz="1020" b="1" dirty="0">
+                <a:solidFill>
+                  <a:srgbClr val="1F1F1F"/>
+                </a:solidFill>
+                <a:latin typeface="Microsoft YaHei" pitchFamily="34" charset="0"/>
+                <a:ea typeface="Microsoft YaHei" pitchFamily="34" charset="-122"/>
+                <a:cs typeface="Microsoft YaHei" pitchFamily="34" charset="-120"/>
+              </a:rPr>
+              <a:t>推理更贴近线上系统工程：准确性、延迟、吞吐和成本需要一起看。</a:t>
+            </a:r>
+            <a:endParaRPr lang="en-US" sz="1020" dirty="0"/>
           </a:p>
         </p:txBody>
       </p:sp>
@@ -15593,11 +15923,11 @@
             </a:avLst>
           </a:prstGeom>
           <a:solidFill>
-            <a:srgbClr val="FFF1F2"/>
-          </a:solidFill>
-          <a:ln w="10160">
-            <a:solidFill>
-              <a:srgbClr val="F2C7CB"/>
+            <a:srgbClr val="FFFFFF"/>
+          </a:solidFill>
+          <a:ln w="9525">
+            <a:solidFill>
+              <a:srgbClr val="DCDCDC"/>
             </a:solidFill>
             <a:prstDash val="solid"/>
           </a:ln>
@@ -15612,7 +15942,7 @@
         <p:spPr>
           <a:xfrm>
             <a:off x="804672" y="5522976"/>
-            <a:ext cx="100584" cy="493776"/>
+            <a:ext cx="91440" cy="493776"/>
           </a:xfrm>
           <a:prstGeom prst="rect">
             <a:avLst/>
@@ -15636,8 +15966,47 @@
         </p:nvSpPr>
         <p:spPr>
           <a:xfrm>
-            <a:off x="1078992" y="5687568"/>
-            <a:ext cx="9921240" cy="118872"/>
+            <a:off x="1051560" y="5632704"/>
+            <a:ext cx="713232" cy="91440"/>
+          </a:xfrm>
+          <a:prstGeom prst="rect">
+            <a:avLst/>
+          </a:prstGeom>
+          <a:noFill/>
+          <a:ln/>
+        </p:spPr>
+        <p:txBody>
+          <a:bodyPr wrap="square" lIns="0" tIns="0" rIns="0" bIns="0" rtlCol="0" anchor="ctr"/>
+          <a:lstStyle/>
+          <a:p>
+            <a:pPr indent="0" marL="0">
+              <a:buNone/>
+            </a:pPr>
+            <a:r>
+              <a:rPr lang="en-US" sz="720" b="1" dirty="0">
+                <a:solidFill>
+                  <a:srgbClr val="C7000B"/>
+                </a:solidFill>
+                <a:latin typeface="Microsoft YaHei" pitchFamily="34" charset="0"/>
+                <a:ea typeface="Microsoft YaHei" pitchFamily="34" charset="-122"/>
+                <a:cs typeface="Microsoft YaHei" pitchFamily="34" charset="-120"/>
+              </a:rPr>
+              <a:t>本页要点</a:t>
+            </a:r>
+            <a:endParaRPr lang="en-US" sz="720" dirty="0"/>
+          </a:p>
+        </p:txBody>
+      </p:sp>
+      <p:sp>
+        <p:nvSpPr>
+          <p:cNvPr id="48" name="Text 46"/>
+          <p:cNvSpPr/>
+          <p:nvPr/>
+        </p:nvSpPr>
+        <p:spPr>
+          <a:xfrm>
+            <a:off x="1874520" y="5687568"/>
+            <a:ext cx="9006840" cy="118872"/>
           </a:xfrm>
           <a:prstGeom prst="rect">
             <a:avLst/>
@@ -15651,13 +16020,13 @@
           </a:bodyPr>
           <a:lstStyle/>
           <a:p>
-            <a:pPr algn="ctr" indent="0" marL="0">
-              <a:buNone/>
-            </a:pPr>
-            <a:r>
-              <a:rPr lang="en-US" sz="1070" b="1" dirty="0">
-                <a:solidFill>
-                  <a:srgbClr val="C7000B"/>
+            <a:pPr algn="l" indent="0" marL="0">
+              <a:buNone/>
+            </a:pPr>
+            <a:r>
+              <a:rPr lang="en-US" sz="1020" b="1" dirty="0">
+                <a:solidFill>
+                  <a:srgbClr val="1F1F1F"/>
                 </a:solidFill>
                 <a:latin typeface="Microsoft YaHei" pitchFamily="34" charset="0"/>
                 <a:ea typeface="Microsoft YaHei" pitchFamily="34" charset="-122"/>
@@ -15665,7 +16034,7 @@
               </a:rPr>
               <a:t>输入 token 越多，前面处理越重；输出 token 越多，后面循环越久。</a:t>
             </a:r>
-            <a:endParaRPr lang="en-US" sz="1070" dirty="0"/>
+            <a:endParaRPr lang="en-US" sz="1020" dirty="0"/>
           </a:p>
         </p:txBody>
       </p:sp>
@@ -17168,11 +17537,11 @@
             </a:avLst>
           </a:prstGeom>
           <a:solidFill>
-            <a:srgbClr val="FFF1F2"/>
-          </a:solidFill>
-          <a:ln w="10160">
-            <a:solidFill>
-              <a:srgbClr val="F2C7CB"/>
+            <a:srgbClr val="FFFFFF"/>
+          </a:solidFill>
+          <a:ln w="9525">
+            <a:solidFill>
+              <a:srgbClr val="DCDCDC"/>
             </a:solidFill>
             <a:prstDash val="solid"/>
           </a:ln>
@@ -17187,7 +17556,7 @@
         <p:spPr>
           <a:xfrm>
             <a:off x="804672" y="5522976"/>
-            <a:ext cx="100584" cy="493776"/>
+            <a:ext cx="91440" cy="493776"/>
           </a:xfrm>
           <a:prstGeom prst="rect">
             <a:avLst/>
@@ -17211,8 +17580,47 @@
         </p:nvSpPr>
         <p:spPr>
           <a:xfrm>
-            <a:off x="1078992" y="5687568"/>
-            <a:ext cx="9921240" cy="118872"/>
+            <a:off x="1051560" y="5632704"/>
+            <a:ext cx="713232" cy="91440"/>
+          </a:xfrm>
+          <a:prstGeom prst="rect">
+            <a:avLst/>
+          </a:prstGeom>
+          <a:noFill/>
+          <a:ln/>
+        </p:spPr>
+        <p:txBody>
+          <a:bodyPr wrap="square" lIns="0" tIns="0" rIns="0" bIns="0" rtlCol="0" anchor="ctr"/>
+          <a:lstStyle/>
+          <a:p>
+            <a:pPr indent="0" marL="0">
+              <a:buNone/>
+            </a:pPr>
+            <a:r>
+              <a:rPr lang="en-US" sz="720" b="1" dirty="0">
+                <a:solidFill>
+                  <a:srgbClr val="C7000B"/>
+                </a:solidFill>
+                <a:latin typeface="Microsoft YaHei" pitchFamily="34" charset="0"/>
+                <a:ea typeface="Microsoft YaHei" pitchFamily="34" charset="-122"/>
+                <a:cs typeface="Microsoft YaHei" pitchFamily="34" charset="-120"/>
+              </a:rPr>
+              <a:t>本页要点</a:t>
+            </a:r>
+            <a:endParaRPr lang="en-US" sz="720" dirty="0"/>
+          </a:p>
+        </p:txBody>
+      </p:sp>
+      <p:sp>
+        <p:nvSpPr>
+          <p:cNvPr id="46" name="Text 44"/>
+          <p:cNvSpPr/>
+          <p:nvPr/>
+        </p:nvSpPr>
+        <p:spPr>
+          <a:xfrm>
+            <a:off x="1874520" y="5687568"/>
+            <a:ext cx="9006840" cy="118872"/>
           </a:xfrm>
           <a:prstGeom prst="rect">
             <a:avLst/>
@@ -17226,21 +17634,21 @@
           </a:bodyPr>
           <a:lstStyle/>
           <a:p>
-            <a:pPr algn="ctr" indent="0" marL="0">
-              <a:buNone/>
-            </a:pPr>
-            <a:r>
-              <a:rPr lang="en-US" sz="1070" b="1" dirty="0">
-                <a:solidFill>
-                  <a:srgbClr val="C7000B"/>
-                </a:solidFill>
-                <a:latin typeface="Microsoft YaHei" pitchFamily="34" charset="0"/>
-                <a:ea typeface="Microsoft YaHei" pitchFamily="34" charset="-122"/>
-                <a:cs typeface="Microsoft YaHei" pitchFamily="34" charset="-120"/>
-              </a:rPr>
-              <a:t>真正的线上推理链路，不只是模型计算，还包括请求治理和服务化能力。</a:t>
-            </a:r>
-            <a:endParaRPr lang="en-US" sz="1070" dirty="0"/>
+            <a:pPr algn="l" indent="0" marL="0">
+              <a:buNone/>
+            </a:pPr>
+            <a:r>
+              <a:rPr lang="en-US" sz="1020" b="1" dirty="0">
+                <a:solidFill>
+                  <a:srgbClr val="1F1F1F"/>
+                </a:solidFill>
+                <a:latin typeface="Microsoft YaHei" pitchFamily="34" charset="0"/>
+                <a:ea typeface="Microsoft YaHei" pitchFamily="34" charset="-122"/>
+                <a:cs typeface="Microsoft YaHei" pitchFamily="34" charset="-120"/>
+              </a:rPr>
+              <a:t>线上推理链路同时包含模型计算、请求治理和服务化能力。</a:t>
+            </a:r>
+            <a:endParaRPr lang="en-US" sz="1020" dirty="0"/>
           </a:p>
         </p:txBody>
       </p:sp>
@@ -18256,11 +18664,11 @@
             </a:avLst>
           </a:prstGeom>
           <a:solidFill>
-            <a:srgbClr val="FFF1F2"/>
-          </a:solidFill>
-          <a:ln w="10160">
-            <a:solidFill>
-              <a:srgbClr val="F2C7CB"/>
+            <a:srgbClr val="FFFFFF"/>
+          </a:solidFill>
+          <a:ln w="9525">
+            <a:solidFill>
+              <a:srgbClr val="DCDCDC"/>
             </a:solidFill>
             <a:prstDash val="solid"/>
           </a:ln>
@@ -18275,7 +18683,7 @@
         <p:spPr>
           <a:xfrm>
             <a:off x="804672" y="5522976"/>
-            <a:ext cx="100584" cy="493776"/>
+            <a:ext cx="91440" cy="493776"/>
           </a:xfrm>
           <a:prstGeom prst="rect">
             <a:avLst/>
@@ -18299,8 +18707,47 @@
         </p:nvSpPr>
         <p:spPr>
           <a:xfrm>
-            <a:off x="1078992" y="5687568"/>
-            <a:ext cx="9921240" cy="118872"/>
+            <a:off x="1051560" y="5632704"/>
+            <a:ext cx="713232" cy="91440"/>
+          </a:xfrm>
+          <a:prstGeom prst="rect">
+            <a:avLst/>
+          </a:prstGeom>
+          <a:noFill/>
+          <a:ln/>
+        </p:spPr>
+        <p:txBody>
+          <a:bodyPr wrap="square" lIns="0" tIns="0" rIns="0" bIns="0" rtlCol="0" anchor="ctr"/>
+          <a:lstStyle/>
+          <a:p>
+            <a:pPr indent="0" marL="0">
+              <a:buNone/>
+            </a:pPr>
+            <a:r>
+              <a:rPr lang="en-US" sz="720" b="1" dirty="0">
+                <a:solidFill>
+                  <a:srgbClr val="C7000B"/>
+                </a:solidFill>
+                <a:latin typeface="Microsoft YaHei" pitchFamily="34" charset="0"/>
+                <a:ea typeface="Microsoft YaHei" pitchFamily="34" charset="-122"/>
+                <a:cs typeface="Microsoft YaHei" pitchFamily="34" charset="-120"/>
+              </a:rPr>
+              <a:t>本页要点</a:t>
+            </a:r>
+            <a:endParaRPr lang="en-US" sz="720" dirty="0"/>
+          </a:p>
+        </p:txBody>
+      </p:sp>
+      <p:sp>
+        <p:nvSpPr>
+          <p:cNvPr id="34" name="Text 32"/>
+          <p:cNvSpPr/>
+          <p:nvPr/>
+        </p:nvSpPr>
+        <p:spPr>
+          <a:xfrm>
+            <a:off x="1874520" y="5687568"/>
+            <a:ext cx="9006840" cy="118872"/>
           </a:xfrm>
           <a:prstGeom prst="rect">
             <a:avLst/>
@@ -18314,13 +18761,13 @@
           </a:bodyPr>
           <a:lstStyle/>
           <a:p>
-            <a:pPr algn="ctr" indent="0" marL="0">
-              <a:buNone/>
-            </a:pPr>
-            <a:r>
-              <a:rPr lang="en-US" sz="1070" b="1" dirty="0">
-                <a:solidFill>
-                  <a:srgbClr val="C7000B"/>
+            <a:pPr algn="l" indent="0" marL="0">
+              <a:buNone/>
+            </a:pPr>
+            <a:r>
+              <a:rPr lang="en-US" sz="1020" b="1" dirty="0">
+                <a:solidFill>
+                  <a:srgbClr val="1F1F1F"/>
                 </a:solidFill>
                 <a:latin typeface="Microsoft YaHei" pitchFamily="34" charset="0"/>
                 <a:ea typeface="Microsoft YaHei" pitchFamily="34" charset="-122"/>
@@ -18328,7 +18775,7 @@
               </a:rPr>
               <a:t>长输入主要压 Prefill；长输出主要压 Decode。</a:t>
             </a:r>
-            <a:endParaRPr lang="en-US" sz="1070" dirty="0"/>
+            <a:endParaRPr lang="en-US" sz="1020" dirty="0"/>
           </a:p>
         </p:txBody>
       </p:sp>
@@ -18655,7 +19102,7 @@
                 <a:ea typeface="Microsoft YaHei" pitchFamily="34" charset="-122"/>
                 <a:cs typeface="Microsoft YaHei" pitchFamily="34" charset="-120"/>
               </a:rPr>
-              <a:t>不要只看总耗时，推理系统通常要同时看用户体验、系统吞吐和资源成本。</a:t>
+              <a:t>推理系统通常同时关注用户体验、系统吞吐和资源成本。</a:t>
             </a:r>
             <a:endParaRPr lang="en-US" sz="1080" dirty="0"/>
           </a:p>
@@ -19633,11 +20080,11 @@
             </a:avLst>
           </a:prstGeom>
           <a:solidFill>
-            <a:srgbClr val="FFF1F2"/>
-          </a:solidFill>
-          <a:ln w="10160">
-            <a:solidFill>
-              <a:srgbClr val="F2C7CB"/>
+            <a:srgbClr val="FFFFFF"/>
+          </a:solidFill>
+          <a:ln w="9525">
+            <a:solidFill>
+              <a:srgbClr val="DCDCDC"/>
             </a:solidFill>
             <a:prstDash val="solid"/>
           </a:ln>
@@ -19652,7 +20099,7 @@
         <p:spPr>
           <a:xfrm>
             <a:off x="804672" y="5522976"/>
-            <a:ext cx="100584" cy="493776"/>
+            <a:ext cx="91440" cy="493776"/>
           </a:xfrm>
           <a:prstGeom prst="rect">
             <a:avLst/>
@@ -19676,8 +20123,47 @@
         </p:nvSpPr>
         <p:spPr>
           <a:xfrm>
-            <a:off x="1078992" y="5687568"/>
-            <a:ext cx="9921240" cy="118872"/>
+            <a:off x="1051560" y="5632704"/>
+            <a:ext cx="713232" cy="91440"/>
+          </a:xfrm>
+          <a:prstGeom prst="rect">
+            <a:avLst/>
+          </a:prstGeom>
+          <a:noFill/>
+          <a:ln/>
+        </p:spPr>
+        <p:txBody>
+          <a:bodyPr wrap="square" lIns="0" tIns="0" rIns="0" bIns="0" rtlCol="0" anchor="ctr"/>
+          <a:lstStyle/>
+          <a:p>
+            <a:pPr indent="0" marL="0">
+              <a:buNone/>
+            </a:pPr>
+            <a:r>
+              <a:rPr lang="en-US" sz="720" b="1" dirty="0">
+                <a:solidFill>
+                  <a:srgbClr val="C7000B"/>
+                </a:solidFill>
+                <a:latin typeface="Microsoft YaHei" pitchFamily="34" charset="0"/>
+                <a:ea typeface="Microsoft YaHei" pitchFamily="34" charset="-122"/>
+                <a:cs typeface="Microsoft YaHei" pitchFamily="34" charset="-120"/>
+              </a:rPr>
+              <a:t>本页要点</a:t>
+            </a:r>
+            <a:endParaRPr lang="en-US" sz="720" dirty="0"/>
+          </a:p>
+        </p:txBody>
+      </p:sp>
+      <p:sp>
+        <p:nvSpPr>
+          <p:cNvPr id="41" name="Text 39"/>
+          <p:cNvSpPr/>
+          <p:nvPr/>
+        </p:nvSpPr>
+        <p:spPr>
+          <a:xfrm>
+            <a:off x="1874520" y="5687568"/>
+            <a:ext cx="9006840" cy="118872"/>
           </a:xfrm>
           <a:prstGeom prst="rect">
             <a:avLst/>
@@ -19691,13 +20177,13 @@
           </a:bodyPr>
           <a:lstStyle/>
           <a:p>
-            <a:pPr algn="ctr" indent="0" marL="0">
-              <a:buNone/>
-            </a:pPr>
-            <a:r>
-              <a:rPr lang="en-US" sz="1070" b="1" dirty="0">
-                <a:solidFill>
-                  <a:srgbClr val="C7000B"/>
+            <a:pPr algn="l" indent="0" marL="0">
+              <a:buNone/>
+            </a:pPr>
+            <a:r>
+              <a:rPr lang="en-US" sz="1020" b="1" dirty="0">
+                <a:solidFill>
+                  <a:srgbClr val="1F1F1F"/>
                 </a:solidFill>
                 <a:latin typeface="Microsoft YaHei" pitchFamily="34" charset="0"/>
                 <a:ea typeface="Microsoft YaHei" pitchFamily="34" charset="-122"/>
@@ -19705,7 +20191,7 @@
               </a:rPr>
               <a:t>TTFT 看启动体验，TPOT 看输出流畅度，Throughput 和显存看系统容量与成本。</a:t>
             </a:r>
-            <a:endParaRPr lang="en-US" sz="1070" dirty="0"/>
+            <a:endParaRPr lang="en-US" sz="1020" dirty="0"/>
           </a:p>
         </p:txBody>
       </p:sp>
@@ -20771,11 +21257,11 @@
             </a:avLst>
           </a:prstGeom>
           <a:solidFill>
-            <a:srgbClr val="FFF1F2"/>
-          </a:solidFill>
-          <a:ln w="10160">
-            <a:solidFill>
-              <a:srgbClr val="F2C7CB"/>
+            <a:srgbClr val="FFFFFF"/>
+          </a:solidFill>
+          <a:ln w="9525">
+            <a:solidFill>
+              <a:srgbClr val="DCDCDC"/>
             </a:solidFill>
             <a:prstDash val="solid"/>
           </a:ln>
@@ -20790,7 +21276,7 @@
         <p:spPr>
           <a:xfrm>
             <a:off x="804672" y="5522976"/>
-            <a:ext cx="100584" cy="493776"/>
+            <a:ext cx="91440" cy="493776"/>
           </a:xfrm>
           <a:prstGeom prst="rect">
             <a:avLst/>
@@ -20814,8 +21300,47 @@
         </p:nvSpPr>
         <p:spPr>
           <a:xfrm>
-            <a:off x="1078992" y="5687568"/>
-            <a:ext cx="9921240" cy="118872"/>
+            <a:off x="1051560" y="5632704"/>
+            <a:ext cx="713232" cy="91440"/>
+          </a:xfrm>
+          <a:prstGeom prst="rect">
+            <a:avLst/>
+          </a:prstGeom>
+          <a:noFill/>
+          <a:ln/>
+        </p:spPr>
+        <p:txBody>
+          <a:bodyPr wrap="square" lIns="0" tIns="0" rIns="0" bIns="0" rtlCol="0" anchor="ctr"/>
+          <a:lstStyle/>
+          <a:p>
+            <a:pPr indent="0" marL="0">
+              <a:buNone/>
+            </a:pPr>
+            <a:r>
+              <a:rPr lang="en-US" sz="720" b="1" dirty="0">
+                <a:solidFill>
+                  <a:srgbClr val="C7000B"/>
+                </a:solidFill>
+                <a:latin typeface="Microsoft YaHei" pitchFamily="34" charset="0"/>
+                <a:ea typeface="Microsoft YaHei" pitchFamily="34" charset="-122"/>
+                <a:cs typeface="Microsoft YaHei" pitchFamily="34" charset="-120"/>
+              </a:rPr>
+              <a:t>本页要点</a:t>
+            </a:r>
+            <a:endParaRPr lang="en-US" sz="720" dirty="0"/>
+          </a:p>
+        </p:txBody>
+      </p:sp>
+      <p:sp>
+        <p:nvSpPr>
+          <p:cNvPr id="36" name="Text 34"/>
+          <p:cNvSpPr/>
+          <p:nvPr/>
+        </p:nvSpPr>
+        <p:spPr>
+          <a:xfrm>
+            <a:off x="1874520" y="5687568"/>
+            <a:ext cx="9006840" cy="118872"/>
           </a:xfrm>
           <a:prstGeom prst="rect">
             <a:avLst/>
@@ -20829,21 +21354,21 @@
           </a:bodyPr>
           <a:lstStyle/>
           <a:p>
-            <a:pPr algn="ctr" indent="0" marL="0">
-              <a:buNone/>
-            </a:pPr>
-            <a:r>
-              <a:rPr lang="en-US" sz="1070" b="1" dirty="0">
-                <a:solidFill>
-                  <a:srgbClr val="C7000B"/>
-                </a:solidFill>
-                <a:latin typeface="Microsoft YaHei" pitchFamily="34" charset="0"/>
-                <a:ea typeface="Microsoft YaHei" pitchFamily="34" charset="-122"/>
-                <a:cs typeface="Microsoft YaHei" pitchFamily="34" charset="-120"/>
-              </a:rPr>
-              <a:t>先拆阶段，再看资源：不要用一个“接口慢”覆盖所有瓶颈。</a:t>
-            </a:r>
-            <a:endParaRPr lang="en-US" sz="1070" dirty="0"/>
+            <a:pPr algn="l" indent="0" marL="0">
+              <a:buNone/>
+            </a:pPr>
+            <a:r>
+              <a:rPr lang="en-US" sz="1020" b="1" dirty="0">
+                <a:solidFill>
+                  <a:srgbClr val="1F1F1F"/>
+                </a:solidFill>
+                <a:latin typeface="Microsoft YaHei" pitchFamily="34" charset="0"/>
+                <a:ea typeface="Microsoft YaHei" pitchFamily="34" charset="-122"/>
+                <a:cs typeface="Microsoft YaHei" pitchFamily="34" charset="-120"/>
+              </a:rPr>
+              <a:t>端到端耗时可以拆成排队、Prefill、Decode、网络和后处理。</a:t>
+            </a:r>
+            <a:endParaRPr lang="en-US" sz="1020" dirty="0"/>
           </a:p>
         </p:txBody>
       </p:sp>
@@ -22205,11 +22730,11 @@
             </a:avLst>
           </a:prstGeom>
           <a:solidFill>
-            <a:srgbClr val="FFF1F2"/>
-          </a:solidFill>
-          <a:ln w="10160">
-            <a:solidFill>
-              <a:srgbClr val="F2C7CB"/>
+            <a:srgbClr val="FFFFFF"/>
+          </a:solidFill>
+          <a:ln w="9525">
+            <a:solidFill>
+              <a:srgbClr val="DCDCDC"/>
             </a:solidFill>
             <a:prstDash val="solid"/>
           </a:ln>
@@ -22224,7 +22749,7 @@
         <p:spPr>
           <a:xfrm>
             <a:off x="804672" y="5522976"/>
-            <a:ext cx="100584" cy="493776"/>
+            <a:ext cx="91440" cy="493776"/>
           </a:xfrm>
           <a:prstGeom prst="rect">
             <a:avLst/>
@@ -22248,8 +22773,47 @@
         </p:nvSpPr>
         <p:spPr>
           <a:xfrm>
-            <a:off x="1078992" y="5687568"/>
-            <a:ext cx="9921240" cy="118872"/>
+            <a:off x="1051560" y="5632704"/>
+            <a:ext cx="713232" cy="91440"/>
+          </a:xfrm>
+          <a:prstGeom prst="rect">
+            <a:avLst/>
+          </a:prstGeom>
+          <a:noFill/>
+          <a:ln/>
+        </p:spPr>
+        <p:txBody>
+          <a:bodyPr wrap="square" lIns="0" tIns="0" rIns="0" bIns="0" rtlCol="0" anchor="ctr"/>
+          <a:lstStyle/>
+          <a:p>
+            <a:pPr indent="0" marL="0">
+              <a:buNone/>
+            </a:pPr>
+            <a:r>
+              <a:rPr lang="en-US" sz="720" b="1" dirty="0">
+                <a:solidFill>
+                  <a:srgbClr val="C7000B"/>
+                </a:solidFill>
+                <a:latin typeface="Microsoft YaHei" pitchFamily="34" charset="0"/>
+                <a:ea typeface="Microsoft YaHei" pitchFamily="34" charset="-122"/>
+                <a:cs typeface="Microsoft YaHei" pitchFamily="34" charset="-120"/>
+              </a:rPr>
+              <a:t>本页要点</a:t>
+            </a:r>
+            <a:endParaRPr lang="en-US" sz="720" dirty="0"/>
+          </a:p>
+        </p:txBody>
+      </p:sp>
+      <p:sp>
+        <p:nvSpPr>
+          <p:cNvPr id="44" name="Text 42"/>
+          <p:cNvSpPr/>
+          <p:nvPr/>
+        </p:nvSpPr>
+        <p:spPr>
+          <a:xfrm>
+            <a:off x="1874520" y="5687568"/>
+            <a:ext cx="9006840" cy="118872"/>
           </a:xfrm>
           <a:prstGeom prst="rect">
             <a:avLst/>
@@ -22263,13 +22827,13 @@
           </a:bodyPr>
           <a:lstStyle/>
           <a:p>
-            <a:pPr algn="ctr" indent="0" marL="0">
-              <a:buNone/>
-            </a:pPr>
-            <a:r>
-              <a:rPr lang="en-US" sz="1070" b="1" dirty="0">
-                <a:solidFill>
-                  <a:srgbClr val="C7000B"/>
+            <a:pPr algn="l" indent="0" marL="0">
+              <a:buNone/>
+            </a:pPr>
+            <a:r>
+              <a:rPr lang="en-US" sz="1020" b="1" dirty="0">
+                <a:solidFill>
+                  <a:srgbClr val="1F1F1F"/>
                 </a:solidFill>
                 <a:latin typeface="Microsoft YaHei" pitchFamily="34" charset="0"/>
                 <a:ea typeface="Microsoft YaHei" pitchFamily="34" charset="-122"/>
@@ -22277,7 +22841,7 @@
               </a:rPr>
               <a:t>KV Cache 解决重复计算，但会把长上下文和高并发转化为显存压力。</a:t>
             </a:r>
-            <a:endParaRPr lang="en-US" sz="1070" dirty="0"/>
+            <a:endParaRPr lang="en-US" sz="1020" dirty="0"/>
           </a:p>
         </p:txBody>
       </p:sp>

</xml_diff>